<commit_message>
Docs: simplify presentation conclusions and add critical review study notes
Remove the critical-review slide and error references from the deck,
rewrite conclusions in plain language, and add a Spanish study guide
explaining each correction with code locations and data sources.

Co-Authored-By: Claude Opus 5.5 <noreply@anthropic.com>
</commit_message>
<xml_diff>
--- a/docs/presentation/Artemis_IV_UdeM.pptx
+++ b/docs/presentation/Artemis_IV_UdeM.pptx
@@ -28,10 +28,9 @@
     <p:sldId id="276" r:id="rId22"/>
     <p:sldId id="277" r:id="rId23"/>
     <p:sldId id="278" r:id="rId24"/>
-    <p:sldId id="279" r:id="rId25"/>
   </p:sldIdLst>
   <p:notesMasterIdLst>
-    <p:notesMasterId r:id="rId26"/>
+    <p:notesMasterId r:id="rId25"/>
   </p:notesMasterIdLst>
   <p:sldSz cx="12192000" cy="6858000"/>
   <p:notesSz cx="6858000" cy="12192000"/>
@@ -130,7 +129,7 @@
   <p:extLst>
     <p:ext uri="{521415D9-36F7-43E2-AB2F-B90AF26B5E84}">
       <p14:sectionLst xmlns:p14="http://schemas.microsoft.com/office/powerpoint/2010/main">
-        <p14:section name="Introducción" id="{53ab7f0f-c777-5b29-6750-34bc906f760f}">
+        <p14:section name="Introducción" id="{2090f3ec-2595-d907-aca1-3bc16fd4d52f}">
           <p14:sldIdLst>
             <p14:sldId id="256"/>
             <p14:sldId id="257"/>
@@ -140,7 +139,7 @@
             <p14:sldId id="261"/>
           </p14:sldIdLst>
         </p14:section>
-        <p14:section name="Fase 1 · Ascenso" id="{cb3be76d-b5e9-7e0e-343d-24c9e7675013}">
+        <p14:section name="Fase 1 · Ascenso" id="{72918961-eca7-1e50-a65e-80ea4ce7c09d}">
           <p14:sldIdLst>
             <p14:sldId id="262"/>
             <p14:sldId id="263"/>
@@ -151,7 +150,7 @@
             <p14:sldId id="268"/>
           </p14:sldIdLst>
         </p14:section>
-        <p14:section name="Fase 2 · Tránsito" id="{997a8800-4801-5970-0106-4d6cdff0ae3e}">
+        <p14:section name="Fase 2 · Tránsito" id="{35179700-9d3a-384a-af6f-99c99d16423f}">
           <p14:sldIdLst>
             <p14:sldId id="269"/>
             <p14:sldId id="270"/>
@@ -160,18 +159,17 @@
             <p14:sldId id="273"/>
           </p14:sldIdLst>
         </p14:section>
-        <p14:section name="Fase 3 · TLI" id="{2d0673c8-6fcd-78f6-624e-1e018dee5881}">
+        <p14:section name="Fase 3 · TLI" id="{77aeb603-d5b5-818b-d5fc-1bf3dcf1a78e}">
           <p14:sldIdLst>
             <p14:sldId id="274"/>
             <p14:sldId id="275"/>
             <p14:sldId id="276"/>
           </p14:sldIdLst>
         </p14:section>
-        <p14:section name="Cierre" id="{cdb6af24-87c6-cf36-5f05-d1bc45187a5d}">
+        <p14:section name="Cierre" id="{a2428688-8996-3c0c-eaad-031f7fd2aaa0}">
           <p14:sldIdLst>
             <p14:sldId id="277"/>
             <p14:sldId id="278"/>
-            <p14:sldId id="279"/>
           </p14:sldIdLst>
         </p14:section>
       </p14:sectionLst>
@@ -754,7 +752,7 @@
           <a:p>
             <a:r>
               <a:rPr lang="en-US" dirty="0"/>
-              <a:t>El guiado tiene tres tramos. En la atmósfera hacemos un giro por gravedad: el empuje sigue la velocidad relativa, con ángulo de ataque cero para minimizar las cargas. Fuera de la atmósfera usamos la ley de tangente lineal, que es la óptima para empuje en el vacío. Los dos parámetros se resolvieron con fsolve para llegar al MECO a 160 km con ángulo de trayectoria cero. El código original usaba solo el giro por gravedad y el cohete se estrellaba a los 388 segundos. La integración usa RK45 con eventos: al detectar el fin de los SRB se descarta su masa seca y se reinicia hasta el MECO.</a:t>
+              <a:t>El guiado tiene tres tramos. En la atmósfera hacemos un giro por gravedad: el empuje sigue la velocidad relativa, con ángulo de ataque cero para minimizar las cargas. Fuera de la atmósfera usamos la ley de tangente lineal, que es la óptima para empuje en el vacío. Los dos parámetros se resolvieron con fsolve para llegar al MECO a 160 km con ángulo de trayectoria cero. El giro por gravedad puro es muy sensible al ángulo inicial; por eso, fuera de la atmósfera, se pasa a la tangente lineal. La integración usa RK45 con eventos: al detectar el fin de los SRB se descarta su masa seca y se reinicia hasta el MECO.</a:t>
             </a:r>
             <a:endParaRPr lang="en-US" dirty="0"/>
           </a:p>
@@ -1106,7 +1104,7 @@
           <a:p>
             <a:r>
               <a:rPr lang="en-US" dirty="0"/>
-              <a:t>En el vacío solo actúan la gravedad terrestre y la lunar. Como usamos coordenadas centradas en la Tierra, y la Tierra también es atraída por la Luna, aparece el término indirecto, que el documento original omitía (el código sí lo tenía). Además corregimos la velocidad angular de la Luna: para que el modelo sea un problema restringido circular de tres cuerpos auténtico, debe cumplir la tercera ley de Kepler con las masas de ambos cuerpos.</a:t>
+              <a:t>En el vacío solo actúan la gravedad terrestre y la lunar. Como usamos coordenadas centradas en la Tierra, y la Tierra también es atraída por la Luna, aparece el término indirecto. Además, la velocidad angular de la Luna se obtiene de la tercera ley de Kepler: para que el modelo sea un problema restringido circular de tres cuerpos auténtico, debe cumplir la tercera ley de Kepler con las masas de ambos cuerpos.</a:t>
             </a:r>
             <a:endParaRPr lang="en-US" dirty="0"/>
           </a:p>
@@ -1370,7 +1368,7 @@
           <a:p>
             <a:r>
               <a:rPr lang="en-US" dirty="0"/>
-              <a:t>Con la Luna presente, la energía respecto a la Tierra no es constante: cambia un 77 % en el encuentro, y eso es física, no un error. El documento original afirmaba que se conservaba. El invariante correcto es la integral de Jacobi del problema restringido. Verlet la conserva con un error relativo de 1e-5, que aparece en la primera hora cerca de la Tierra y luego se mantiene plano.</a:t>
+              <a:t>Con la Luna presente, la energía respecto a la Tierra no es constante: cambia un 77 % en el encuentro, y eso es física, no un error. El invariante correcto es la integral de Jacobi del problema restringido. Verlet la conserva con un error relativo de 1e-5, que aparece en la primera hora cerca de la Tierra y luego se mantiene plano.</a:t>
             </a:r>
             <a:endParaRPr lang="en-US" dirty="0"/>
           </a:p>
@@ -1546,7 +1544,7 @@
           <a:p>
             <a:r>
               <a:rPr lang="en-US" dirty="0"/>
-              <a:t>La charla sigue el orden de la misión: contexto, luego las tres fases que simulamos y al final la revisión crítica del código, las conclusiones y el trabajo futuro.</a:t>
+              <a:t>La charla sigue el orden de la misión: contexto, luego las tres fases que simulamos y al final las conclusiones físicas y el trabajo futuro.</a:t>
             </a:r>
             <a:endParaRPr lang="en-US" dirty="0"/>
           </a:p>
@@ -1634,7 +1632,7 @@
           <a:p>
             <a:r>
               <a:rPr lang="en-US" dirty="0"/>
-              <a:t>La TLI es un problema de valores en la frontera: conocemos dónde empezamos y dónde queremos estar en 4 días, pero no la velocidad inicial. Lo resolvemos con el método del disparo: F(Δv) es el error de posición al llegar, y con Newton y un jacobiano por diferencias centrales iteramos hasta anularlo. Newton solo converge si arrancamos cerca, y la semilla original estaba a 677 000 km del objetivo. La mejoramos resolviendo la ecuación de Kepler, que nos dice dónde encender para que el apogeo coincida con la Luna. Así el residuo inicial cae a 24 000 km, causado solo por la gravedad lunar.</a:t>
+              <a:t>La TLI es un problema de valores en la frontera: conocemos dónde empezamos y dónde queremos estar en 4 días, pero no la velocidad inicial. Lo resolvemos con el método del disparo: F(Δv) es el error de posición al llegar, y con Newton y un jacobiano por diferencias centrales iteramos hasta anularlo. Newton solo converge si arrancamos cerca, así que la semilla se obtiene resolviendo la ecuación de Kepler, que nos dice dónde encender para que el apogeo coincida con la Luna. Así el residuo inicial cae a 24 000 km, causado solo por la gravedad lunar.</a:t>
             </a:r>
             <a:endParaRPr lang="en-US" dirty="0"/>
           </a:p>
@@ -1810,7 +1808,7 @@
           <a:p>
             <a:r>
               <a:rPr lang="en-US" dirty="0"/>
-              <a:t>Esta es la revisión crítica que hicimos antes de presentar resultados. Encontramos siete problemas: los SRB que violaban la conservación de masa, una trayectoria que se estrellaba, eventos con constantes fijas, una velocidad lunar inconsistente, un diagnóstico de energía que no era un invariante, un targeting que no convergía y errores de formulación en el documento. Cada uno tiene ahora una prueba automática que lo protege.</a:t>
+              <a:t>Para cerrar, cuatro ideas. Primero, el simulador reproduce el vuelo real: los resultados del ascenso y del viaje a la Luna son del mismo orden que los de la misión real. Segundo, no existe un único método para todo: la atmósfera requiere un método adaptativo y el vacío uno que respete la energía. Tercero, para viajes largos el método simpléctico es mejor, porque su error de energía no crece con el tiempo. Y cuarto, la misión es factible: la etapa EUS tiene combustible suficiente para entrar en órbita y llegar a la Luna. Como trabajo futuro quedan la órbita de Gateway, el descenso a la superficie lunar y modelos más realistas.</a:t>
             </a:r>
             <a:endParaRPr lang="en-US" dirty="0"/>
           </a:p>
@@ -1898,7 +1896,7 @@
           <a:p>
             <a:r>
               <a:rPr lang="en-US" dirty="0"/>
-              <a:t>En conclusión: tenemos un simulador verificado, con resultados coherentes con el vehículo real, que demuestra con datos por qué cada régimen requiere su integrador. Como trabajo futuro quedan la órbita NRHO de Gateway, el descenso con el campo gravitatorio lunar real de GRAIL y efemérides de alta fidelidad.</a:t>
+              <a:t>Gracias. Quedamos atentos a sus preguntas. Si quiere, podemos abrir el código y mostrar cualquiera de las funciones citadas en las diapositivas.</a:t>
             </a:r>
             <a:endParaRPr lang="en-US" dirty="0"/>
           </a:p>
@@ -1922,94 +1920,6 @@
             <a:fld id="{F7021451-1387-4CA6-816F-3879F97B5CBC}" type="slidenum">
               <a:rPr lang="en-US"/>
               <a:t>23</a:t>
-            </a:fld>
-            <a:endParaRPr lang="en-US"/>
-          </a:p>
-        </p:txBody>
-      </p:sp>
-    </p:spTree>
-    <p:extLst>
-      <p:ext uri="{BB962C8B-B14F-4D97-AF65-F5344CB8AC3E}">
-        <p14:creationId xmlns:p14="http://schemas.microsoft.com/office/powerpoint/2010/main" val="1024086991"/>
-      </p:ext>
-    </p:extLst>
-  </p:cSld>
-  <p:clrMapOvr>
-    <a:masterClrMapping/>
-  </p:clrMapOvr>
-</p:notes>
-</file>
-
-<file path=ppt/notesSlides/notesSlide24.xml><?xml version="1.0" encoding="utf-8"?>
-<p:notes xmlns:a="http://schemas.openxmlformats.org/drawingml/2006/main" xmlns:r="http://schemas.openxmlformats.org/officeDocument/2006/relationships" xmlns:p="http://schemas.openxmlformats.org/presentationml/2006/main">
-  <p:cSld>
-    <p:spTree>
-      <p:nvGrpSpPr>
-        <p:cNvPr id="1" name=""/>
-        <p:cNvGrpSpPr/>
-        <p:nvPr/>
-      </p:nvGrpSpPr>
-      <p:grpSpPr>
-        <a:xfrm>
-          <a:off x="0" y="0"/>
-          <a:ext cx="0" cy="0"/>
-          <a:chOff x="0" y="0"/>
-          <a:chExt cx="0" cy="0"/>
-        </a:xfrm>
-      </p:grpSpPr>
-      <p:sp>
-        <p:nvSpPr>
-          <p:cNvPr id="2" name="Slide Image Placeholder 1"/>
-          <p:cNvSpPr>
-            <a:spLocks noGrp="1" noRot="1" noChangeAspect="1"/>
-          </p:cNvSpPr>
-          <p:nvPr>
-            <p:ph type="sldImg"/>
-          </p:nvPr>
-        </p:nvSpPr>
-        <p:spPr/>
-      </p:sp>
-      <p:sp>
-        <p:nvSpPr>
-          <p:cNvPr id="3" name="Notes Placeholder 2"/>
-          <p:cNvSpPr>
-            <a:spLocks noGrp="1"/>
-          </p:cNvSpPr>
-          <p:nvPr>
-            <p:ph type="body" idx="1"/>
-          </p:nvPr>
-        </p:nvSpPr>
-        <p:spPr/>
-        <p:txBody>
-          <a:bodyPr/>
-          <a:lstStyle/>
-          <a:p>
-            <a:r>
-              <a:rPr lang="en-US" dirty="0"/>
-              <a:t>Gracias. Quedamos atentos a sus preguntas. Si quiere, podemos abrir el código y mostrar cualquiera de las funciones citadas en las diapositivas.</a:t>
-            </a:r>
-            <a:endParaRPr lang="en-US" dirty="0"/>
-          </a:p>
-        </p:txBody>
-      </p:sp>
-      <p:sp>
-        <p:nvSpPr>
-          <p:cNvPr id="4" name="Slide Number Placeholder 3"/>
-          <p:cNvSpPr>
-            <a:spLocks noGrp="1"/>
-          </p:cNvSpPr>
-          <p:nvPr>
-            <p:ph type="sldNum" sz="quarter" idx="10"/>
-          </p:nvPr>
-        </p:nvSpPr>
-        <p:spPr/>
-        <p:txBody>
-          <a:bodyPr/>
-          <a:lstStyle/>
-          <a:p>
-            <a:fld id="{F7021451-1387-4CA6-816F-3879F97B5CBC}" type="slidenum">
-              <a:rPr lang="en-US"/>
-              <a:t>24</a:t>
             </a:fld>
             <a:endParaRPr lang="en-US"/>
           </a:p>
@@ -2514,7 +2424,7 @@
           <a:p>
             <a:r>
               <a:rPr lang="en-US" dirty="0"/>
-              <a:t>Escribimos las ecuaciones en el marco geocéntrico inercial ECI. El estado tiene siete componentes: posición, velocidad y masa. La aceleración suma empuje, arrastre y gravedad. Detalle importante: en un marco inercial no hay Coriolis; la rotación de la Tierra entra por la velocidad relativa al aire y por la velocidad inicial de 408 m/s del LC-39B. El borrador original mezclaba ambos marcos y lo corregimos. Todo esto está en make_ascent_derivatives, que devuelve la función f(t, Y) que recibe solve_ivp.</a:t>
+              <a:t>Escribimos las ecuaciones en el marco geocéntrico inercial ECI. El estado tiene siete componentes: posición, velocidad y masa. La aceleración suma empuje, arrastre y gravedad. Detalle importante: en un marco inercial no hay Coriolis; la rotación de la Tierra entra por la velocidad relativa al aire y por la velocidad inicial de 408 m/s del LC-39B. Por eso se lanza hacia el este: la rotación terrestre regala unos 408 m/s. Todo esto está en make_ascent_derivatives, que devuelve la función f(t, Y) que recibe solve_ivp.</a:t>
             </a:r>
             <a:endParaRPr lang="en-US" dirty="0"/>
           </a:p>
@@ -2602,7 +2512,7 @@
           <a:p>
             <a:r>
               <a:rPr lang="en-US" dirty="0"/>
-              <a:t>El empuje real depende de la presión: T = T_vac - p_a A_e. Aquí encontramos el primer error físico: con empuje constante los SRB se quedaban sin propelente a los 103 segundos, pero el código los mantenía encendidos hasta los 126 y les restaba masa de la etapa central. Lo corregimos con un perfil de empuje regresivo, como el real, escalado con un factor k que garantiza la conservación de masa. Ese factor da 1.0033: los datos públicos son coherentes. Hay una prueba automática que integra el flujo másico y comprueba que da exactamente la masa de propelente.</a:t>
+              <a:t>El empuje real depende de la presión: T = T_vac - p_a A_e. Los SRB no empujan de forma constante: el grano de combustible sólido se talla para dar un empuje regresivo, alto al despegue y menor cerca de Max-Q. Modelamos ese perfil y lo escalamos con un factor k que garantiza la conservación de la masa: en 126 segundos se quema exactamente el propelente de los SRB. Ese factor da 1.0033: los datos públicos son coherentes. Hay una prueba automática que integra el flujo másico y comprueba que da exactamente la masa de propelente.</a:t>
             </a:r>
             <a:endParaRPr lang="en-US" dirty="0"/>
           </a:p>
@@ -7702,7 +7612,7 @@
                   <a:srgbClr val="1B1B1F"/>
                 </a:solidFill>
               </a:rPr>
-              <a:t>El origen (la Tierra) también cae hacia la Luna. En coordenadas geocéntricas hay que restar esa aceleración, −μ_L r_L/|r_L|³; el borrador lo omitía.</a:t>
+              <a:t>El origen (la Tierra) también cae hacia la Luna. En coordenadas geocéntricas hay que restar esa aceleración, −μ_L r_L/|r_L|³ (marco no inercial).</a:t>
             </a:r>
             <a:endParaRPr lang="en-US" sz="1400" dirty="0"/>
           </a:p>
@@ -7828,7 +7738,7 @@
                   <a:srgbClr val="1B1B1F"/>
                 </a:solidFill>
               </a:rPr>
-              <a:t>El valor sidéreo de 2.6617e-6 no satisface la tercera ley de Kepler con μ_E + μ_L; con ese valor, Jacobi no se conservaba.</a:t>
+              <a:t>Con n kepleriano el modelo es un CR3BP exacto y la integral de Jacobi se conserva. El valor observado (2.6617e-6) incluye la perturbación solar.</a:t>
             </a:r>
             <a:endParaRPr lang="en-US" sz="1300" dirty="0"/>
           </a:p>
@@ -10139,7 +10049,7 @@
                   <a:srgbClr val="52514E"/>
                 </a:solidFill>
               </a:rPr>
-              <a:t>Errores corregidos, conclusiones y trabajo futuro</a:t>
+              <a:t>Resultados físicos, conclusiones y trabajo futuro</a:t>
             </a:r>
             <a:endParaRPr lang="en-US" sz="1400" dirty="0"/>
           </a:p>
@@ -10572,7 +10482,7 @@
                   <a:srgbClr val="1B1B1F"/>
                 </a:solidFill>
               </a:rPr>
-              <a:t>Con la semilla vis-viva el residuo inicial era de 677 000 km y Newton no convergía. Resolvemos la ecuación de Kepler:</a:t>
+              <a:t>Newton converge solo si arranca cerca de la solución, y la Luna se mueve unos 52° en 4 días. Resolvemos la ecuación de Kepler:</a:t>
             </a:r>
             <a:endParaRPr lang="en-US" sz="1350" dirty="0"/>
           </a:p>
@@ -11282,1533 +11192,49 @@
                 <a:ea typeface="Cambria" pitchFamily="34" charset="-122"/>
                 <a:cs typeface="Cambria" pitchFamily="34" charset="-120"/>
               </a:rPr>
-              <a:t>Revisión crítica: errores encontrados y corregidos</a:t>
+              <a:t>Conclusiones: lo que nos dice la física</a:t>
             </a:r>
             <a:endParaRPr lang="en-US" sz="3000" dirty="0"/>
           </a:p>
         </p:txBody>
       </p:sp>
-      <p:graphicFrame>
-        <p:nvGraphicFramePr>
-          <p:cNvPr id="23" name="Table 0"/>
-          <p:cNvGraphicFramePr>
-            <a:graphicFrameLocks noGrp="1"/>
-          </p:cNvGraphicFramePr>
-          <p:nvPr>
-            <p:extLst>
-              <p:ext uri="{D42A27DB-BD31-4B8C-83A1-F6EECF244321}">
-                <p14:modId xmlns:p14="http://schemas.microsoft.com/office/powerpoint/2010/main" val="1579011935"/>
-              </p:ext>
-            </p:extLst>
-          </p:nvPr>
-        </p:nvGraphicFramePr>
-        <p:xfrm>
-          <a:off x="548640" y="1234440"/>
-          <a:ext cx="11064240" cy="914400"/>
-        </p:xfrm>
-        <a:graphic>
-          <a:graphicData uri="http://schemas.openxmlformats.org/drawingml/2006/table">
-            <a:tbl>
-              <a:tblPr/>
-              <a:tblGrid>
-                <a:gridCol w="2743200"/>
-                <a:gridCol w="4206240"/>
-                <a:gridCol w="4114800"/>
-              </a:tblGrid>
-              <a:tr h="475488">
-                <a:tc>
-                  <a:txBody>
-                    <a:bodyPr/>
-                    <a:lstStyle/>
-                    <a:p>
-                      <a:pPr indent="0" marL="0">
-                        <a:buNone/>
-                      </a:pPr>
-                      <a:r>
-                        <a:rPr lang="en-US" sz="1350" b="1" dirty="0">
-                          <a:solidFill>
-                            <a:srgbClr val="FFFFFF"/>
-                          </a:solidFill>
-                        </a:rPr>
-                        <a:t>Aspecto</a:t>
-                      </a:r>
-                      <a:endParaRPr lang="en-US" sz="1350" dirty="0"/>
-                    </a:p>
-                  </a:txBody>
-                  <a:tcPr marL="73152" marR="73152" marT="73152" marB="73152" anchor="ctr">
-                    <a:lnL w="6350" cap="flat" cmpd="sng" algn="ctr">
-                      <a:solidFill>
-                        <a:srgbClr val="D5DAE1"/>
-                      </a:solidFill>
-                      <a:prstDash val="solid"/>
-                      <a:round/>
-                      <a:headEnd type="none" w="med" len="med"/>
-                      <a:tailEnd type="none" w="med" len="med"/>
-                    </a:lnL>
-                    <a:lnR w="6350" cap="flat" cmpd="sng" algn="ctr">
-                      <a:solidFill>
-                        <a:srgbClr val="D5DAE1"/>
-                      </a:solidFill>
-                      <a:prstDash val="solid"/>
-                      <a:round/>
-                      <a:headEnd type="none" w="med" len="med"/>
-                      <a:tailEnd type="none" w="med" len="med"/>
-                    </a:lnR>
-                    <a:lnT w="6350" cap="flat" cmpd="sng" algn="ctr">
-                      <a:solidFill>
-                        <a:srgbClr val="D5DAE1"/>
-                      </a:solidFill>
-                      <a:prstDash val="solid"/>
-                      <a:round/>
-                      <a:headEnd type="none" w="med" len="med"/>
-                      <a:tailEnd type="none" w="med" len="med"/>
-                    </a:lnT>
-                    <a:lnB w="6350" cap="flat" cmpd="sng" algn="ctr">
-                      <a:solidFill>
-                        <a:srgbClr val="D5DAE1"/>
-                      </a:solidFill>
-                      <a:prstDash val="solid"/>
-                      <a:round/>
-                      <a:headEnd type="none" w="med" len="med"/>
-                      <a:tailEnd type="none" w="med" len="med"/>
-                    </a:lnB>
-                    <a:solidFill>
-                      <a:srgbClr val="0B1D3A"/>
-                    </a:solidFill>
-                  </a:tcPr>
-                </a:tc>
-                <a:tc>
-                  <a:txBody>
-                    <a:bodyPr/>
-                    <a:lstStyle/>
-                    <a:p>
-                      <a:pPr indent="0" marL="0">
-                        <a:buNone/>
-                      </a:pPr>
-                      <a:r>
-                        <a:rPr lang="en-US" sz="1350" b="1" dirty="0">
-                          <a:solidFill>
-                            <a:srgbClr val="FFFFFF"/>
-                          </a:solidFill>
-                        </a:rPr>
-                        <a:t>Problema</a:t>
-                      </a:r>
-                      <a:endParaRPr lang="en-US" sz="1350" dirty="0"/>
-                    </a:p>
-                  </a:txBody>
-                  <a:tcPr marL="73152" marR="73152" marT="73152" marB="73152" anchor="ctr">
-                    <a:lnL w="6350" cap="flat" cmpd="sng" algn="ctr">
-                      <a:solidFill>
-                        <a:srgbClr val="D5DAE1"/>
-                      </a:solidFill>
-                      <a:prstDash val="solid"/>
-                      <a:round/>
-                      <a:headEnd type="none" w="med" len="med"/>
-                      <a:tailEnd type="none" w="med" len="med"/>
-                    </a:lnL>
-                    <a:lnR w="6350" cap="flat" cmpd="sng" algn="ctr">
-                      <a:solidFill>
-                        <a:srgbClr val="D5DAE1"/>
-                      </a:solidFill>
-                      <a:prstDash val="solid"/>
-                      <a:round/>
-                      <a:headEnd type="none" w="med" len="med"/>
-                      <a:tailEnd type="none" w="med" len="med"/>
-                    </a:lnR>
-                    <a:lnT w="6350" cap="flat" cmpd="sng" algn="ctr">
-                      <a:solidFill>
-                        <a:srgbClr val="D5DAE1"/>
-                      </a:solidFill>
-                      <a:prstDash val="solid"/>
-                      <a:round/>
-                      <a:headEnd type="none" w="med" len="med"/>
-                      <a:tailEnd type="none" w="med" len="med"/>
-                    </a:lnT>
-                    <a:lnB w="6350" cap="flat" cmpd="sng" algn="ctr">
-                      <a:solidFill>
-                        <a:srgbClr val="D5DAE1"/>
-                      </a:solidFill>
-                      <a:prstDash val="solid"/>
-                      <a:round/>
-                      <a:headEnd type="none" w="med" len="med"/>
-                      <a:tailEnd type="none" w="med" len="med"/>
-                    </a:lnB>
-                    <a:solidFill>
-                      <a:srgbClr val="0B1D3A"/>
-                    </a:solidFill>
-                  </a:tcPr>
-                </a:tc>
-                <a:tc>
-                  <a:txBody>
-                    <a:bodyPr/>
-                    <a:lstStyle/>
-                    <a:p>
-                      <a:pPr indent="0" marL="0">
-                        <a:buNone/>
-                      </a:pPr>
-                      <a:r>
-                        <a:rPr lang="en-US" sz="1350" b="1" dirty="0">
-                          <a:solidFill>
-                            <a:srgbClr val="FFFFFF"/>
-                          </a:solidFill>
-                        </a:rPr>
-                        <a:t>Corrección</a:t>
-                      </a:r>
-                      <a:endParaRPr lang="en-US" sz="1350" dirty="0"/>
-                    </a:p>
-                  </a:txBody>
-                  <a:tcPr marL="73152" marR="73152" marT="73152" marB="73152" anchor="ctr">
-                    <a:lnL w="6350" cap="flat" cmpd="sng" algn="ctr">
-                      <a:solidFill>
-                        <a:srgbClr val="D5DAE1"/>
-                      </a:solidFill>
-                      <a:prstDash val="solid"/>
-                      <a:round/>
-                      <a:headEnd type="none" w="med" len="med"/>
-                      <a:tailEnd type="none" w="med" len="med"/>
-                    </a:lnL>
-                    <a:lnR w="6350" cap="flat" cmpd="sng" algn="ctr">
-                      <a:solidFill>
-                        <a:srgbClr val="D5DAE1"/>
-                      </a:solidFill>
-                      <a:prstDash val="solid"/>
-                      <a:round/>
-                      <a:headEnd type="none" w="med" len="med"/>
-                      <a:tailEnd type="none" w="med" len="med"/>
-                    </a:lnR>
-                    <a:lnT w="6350" cap="flat" cmpd="sng" algn="ctr">
-                      <a:solidFill>
-                        <a:srgbClr val="D5DAE1"/>
-                      </a:solidFill>
-                      <a:prstDash val="solid"/>
-                      <a:round/>
-                      <a:headEnd type="none" w="med" len="med"/>
-                      <a:tailEnd type="none" w="med" len="med"/>
-                    </a:lnT>
-                    <a:lnB w="6350" cap="flat" cmpd="sng" algn="ctr">
-                      <a:solidFill>
-                        <a:srgbClr val="D5DAE1"/>
-                      </a:solidFill>
-                      <a:prstDash val="solid"/>
-                      <a:round/>
-                      <a:headEnd type="none" w="med" len="med"/>
-                      <a:tailEnd type="none" w="med" len="med"/>
-                    </a:lnB>
-                    <a:solidFill>
-                      <a:srgbClr val="0B1D3A"/>
-                    </a:solidFill>
-                  </a:tcPr>
-                </a:tc>
-              </a:tr>
-              <a:tr h="475488">
-                <a:tc>
-                  <a:txBody>
-                    <a:bodyPr/>
-                    <a:lstStyle/>
-                    <a:p>
-                      <a:pPr indent="0" marL="0">
-                        <a:buNone/>
-                      </a:pPr>
-                      <a:r>
-                        <a:rPr lang="en-US" sz="1350" b="1" dirty="0">
-                          <a:solidFill>
-                            <a:srgbClr val="0B1D3A"/>
-                          </a:solidFill>
-                        </a:rPr>
-                        <a:t>Masa de los SRB</a:t>
-                      </a:r>
-                      <a:endParaRPr lang="en-US" sz="1350" dirty="0"/>
-                    </a:p>
-                  </a:txBody>
-                  <a:tcPr marL="73152" marR="73152" marT="73152" marB="73152" anchor="ctr">
-                    <a:lnL w="6350" cap="flat" cmpd="sng" algn="ctr">
-                      <a:solidFill>
-                        <a:srgbClr val="D5DAE1"/>
-                      </a:solidFill>
-                      <a:prstDash val="solid"/>
-                      <a:round/>
-                      <a:headEnd type="none" w="med" len="med"/>
-                      <a:tailEnd type="none" w="med" len="med"/>
-                    </a:lnL>
-                    <a:lnR w="6350" cap="flat" cmpd="sng" algn="ctr">
-                      <a:solidFill>
-                        <a:srgbClr val="D5DAE1"/>
-                      </a:solidFill>
-                      <a:prstDash val="solid"/>
-                      <a:round/>
-                      <a:headEnd type="none" w="med" len="med"/>
-                      <a:tailEnd type="none" w="med" len="med"/>
-                    </a:lnR>
-                    <a:lnT w="6350" cap="flat" cmpd="sng" algn="ctr">
-                      <a:solidFill>
-                        <a:srgbClr val="D5DAE1"/>
-                      </a:solidFill>
-                      <a:prstDash val="solid"/>
-                      <a:round/>
-                      <a:headEnd type="none" w="med" len="med"/>
-                      <a:tailEnd type="none" w="med" len="med"/>
-                    </a:lnT>
-                    <a:lnB w="6350" cap="flat" cmpd="sng" algn="ctr">
-                      <a:solidFill>
-                        <a:srgbClr val="D5DAE1"/>
-                      </a:solidFill>
-                      <a:prstDash val="solid"/>
-                      <a:round/>
-                      <a:headEnd type="none" w="med" len="med"/>
-                      <a:tailEnd type="none" w="med" len="med"/>
-                    </a:lnB>
-                    <a:solidFill>
-                      <a:srgbClr val="FFFFFF"/>
-                    </a:solidFill>
-                  </a:tcPr>
-                </a:tc>
-                <a:tc>
-                  <a:txBody>
-                    <a:bodyPr/>
-                    <a:lstStyle/>
-                    <a:p>
-                      <a:pPr indent="0" marL="0">
-                        <a:buNone/>
-                      </a:pPr>
-                      <a:r>
-                        <a:rPr lang="en-US" sz="1350" dirty="0">
-                          <a:solidFill>
-                            <a:srgbClr val="B54A1C"/>
-                          </a:solidFill>
-                        </a:rPr>
-                        <a:t>Agotados a 103 s, encendidos hasta 126 s</a:t>
-                      </a:r>
-                      <a:endParaRPr lang="en-US" sz="1350" dirty="0"/>
-                    </a:p>
-                  </a:txBody>
-                  <a:tcPr marL="73152" marR="73152" marT="73152" marB="73152" anchor="ctr">
-                    <a:lnL w="6350" cap="flat" cmpd="sng" algn="ctr">
-                      <a:solidFill>
-                        <a:srgbClr val="D5DAE1"/>
-                      </a:solidFill>
-                      <a:prstDash val="solid"/>
-                      <a:round/>
-                      <a:headEnd type="none" w="med" len="med"/>
-                      <a:tailEnd type="none" w="med" len="med"/>
-                    </a:lnL>
-                    <a:lnR w="6350" cap="flat" cmpd="sng" algn="ctr">
-                      <a:solidFill>
-                        <a:srgbClr val="D5DAE1"/>
-                      </a:solidFill>
-                      <a:prstDash val="solid"/>
-                      <a:round/>
-                      <a:headEnd type="none" w="med" len="med"/>
-                      <a:tailEnd type="none" w="med" len="med"/>
-                    </a:lnR>
-                    <a:lnT w="6350" cap="flat" cmpd="sng" algn="ctr">
-                      <a:solidFill>
-                        <a:srgbClr val="D5DAE1"/>
-                      </a:solidFill>
-                      <a:prstDash val="solid"/>
-                      <a:round/>
-                      <a:headEnd type="none" w="med" len="med"/>
-                      <a:tailEnd type="none" w="med" len="med"/>
-                    </a:lnT>
-                    <a:lnB w="6350" cap="flat" cmpd="sng" algn="ctr">
-                      <a:solidFill>
-                        <a:srgbClr val="D5DAE1"/>
-                      </a:solidFill>
-                      <a:prstDash val="solid"/>
-                      <a:round/>
-                      <a:headEnd type="none" w="med" len="med"/>
-                      <a:tailEnd type="none" w="med" len="med"/>
-                    </a:lnB>
-                    <a:solidFill>
-                      <a:srgbClr val="FFFFFF"/>
-                    </a:solidFill>
-                  </a:tcPr>
-                </a:tc>
-                <a:tc>
-                  <a:txBody>
-                    <a:bodyPr/>
-                    <a:lstStyle/>
-                    <a:p>
-                      <a:pPr indent="0" marL="0">
-                        <a:buNone/>
-                      </a:pPr>
-                      <a:r>
-                        <a:rPr lang="en-US" sz="1350" dirty="0">
-                          <a:solidFill>
-                            <a:srgbClr val="137A55"/>
-                          </a:solidFill>
-                        </a:rPr>
-                        <a:t>Perfil f(t) con k = 1.0033</a:t>
-                      </a:r>
-                      <a:endParaRPr lang="en-US" sz="1350" dirty="0"/>
-                    </a:p>
-                  </a:txBody>
-                  <a:tcPr marL="73152" marR="73152" marT="73152" marB="73152" anchor="ctr">
-                    <a:lnL w="6350" cap="flat" cmpd="sng" algn="ctr">
-                      <a:solidFill>
-                        <a:srgbClr val="D5DAE1"/>
-                      </a:solidFill>
-                      <a:prstDash val="solid"/>
-                      <a:round/>
-                      <a:headEnd type="none" w="med" len="med"/>
-                      <a:tailEnd type="none" w="med" len="med"/>
-                    </a:lnL>
-                    <a:lnR w="6350" cap="flat" cmpd="sng" algn="ctr">
-                      <a:solidFill>
-                        <a:srgbClr val="D5DAE1"/>
-                      </a:solidFill>
-                      <a:prstDash val="solid"/>
-                      <a:round/>
-                      <a:headEnd type="none" w="med" len="med"/>
-                      <a:tailEnd type="none" w="med" len="med"/>
-                    </a:lnR>
-                    <a:lnT w="6350" cap="flat" cmpd="sng" algn="ctr">
-                      <a:solidFill>
-                        <a:srgbClr val="D5DAE1"/>
-                      </a:solidFill>
-                      <a:prstDash val="solid"/>
-                      <a:round/>
-                      <a:headEnd type="none" w="med" len="med"/>
-                      <a:tailEnd type="none" w="med" len="med"/>
-                    </a:lnT>
-                    <a:lnB w="6350" cap="flat" cmpd="sng" algn="ctr">
-                      <a:solidFill>
-                        <a:srgbClr val="D5DAE1"/>
-                      </a:solidFill>
-                      <a:prstDash val="solid"/>
-                      <a:round/>
-                      <a:headEnd type="none" w="med" len="med"/>
-                      <a:tailEnd type="none" w="med" len="med"/>
-                    </a:lnB>
-                    <a:solidFill>
-                      <a:srgbClr val="FFFFFF"/>
-                    </a:solidFill>
-                  </a:tcPr>
-                </a:tc>
-              </a:tr>
-              <a:tr h="475488">
-                <a:tc>
-                  <a:txBody>
-                    <a:bodyPr/>
-                    <a:lstStyle/>
-                    <a:p>
-                      <a:pPr indent="0" marL="0">
-                        <a:buNone/>
-                      </a:pPr>
-                      <a:r>
-                        <a:rPr lang="en-US" sz="1350" b="1" dirty="0">
-                          <a:solidFill>
-                            <a:srgbClr val="0B1D3A"/>
-                          </a:solidFill>
-                        </a:rPr>
-                        <a:t>Trayectoria de ascenso</a:t>
-                      </a:r>
-                      <a:endParaRPr lang="en-US" sz="1350" dirty="0"/>
-                    </a:p>
-                  </a:txBody>
-                  <a:tcPr marL="73152" marR="73152" marT="73152" marB="73152" anchor="ctr">
-                    <a:lnL w="6350" cap="flat" cmpd="sng" algn="ctr">
-                      <a:solidFill>
-                        <a:srgbClr val="D5DAE1"/>
-                      </a:solidFill>
-                      <a:prstDash val="solid"/>
-                      <a:round/>
-                      <a:headEnd type="none" w="med" len="med"/>
-                      <a:tailEnd type="none" w="med" len="med"/>
-                    </a:lnL>
-                    <a:lnR w="6350" cap="flat" cmpd="sng" algn="ctr">
-                      <a:solidFill>
-                        <a:srgbClr val="D5DAE1"/>
-                      </a:solidFill>
-                      <a:prstDash val="solid"/>
-                      <a:round/>
-                      <a:headEnd type="none" w="med" len="med"/>
-                      <a:tailEnd type="none" w="med" len="med"/>
-                    </a:lnR>
-                    <a:lnT w="6350" cap="flat" cmpd="sng" algn="ctr">
-                      <a:solidFill>
-                        <a:srgbClr val="D5DAE1"/>
-                      </a:solidFill>
-                      <a:prstDash val="solid"/>
-                      <a:round/>
-                      <a:headEnd type="none" w="med" len="med"/>
-                      <a:tailEnd type="none" w="med" len="med"/>
-                    </a:lnT>
-                    <a:lnB w="6350" cap="flat" cmpd="sng" algn="ctr">
-                      <a:solidFill>
-                        <a:srgbClr val="D5DAE1"/>
-                      </a:solidFill>
-                      <a:prstDash val="solid"/>
-                      <a:round/>
-                      <a:headEnd type="none" w="med" len="med"/>
-                      <a:tailEnd type="none" w="med" len="med"/>
-                    </a:lnB>
-                    <a:solidFill>
-                      <a:srgbClr val="EEF2F7"/>
-                    </a:solidFill>
-                  </a:tcPr>
-                </a:tc>
-                <a:tc>
-                  <a:txBody>
-                    <a:bodyPr/>
-                    <a:lstStyle/>
-                    <a:p>
-                      <a:pPr indent="0" marL="0">
-                        <a:buNone/>
-                      </a:pPr>
-                      <a:r>
-                        <a:rPr lang="en-US" sz="1350" dirty="0">
-                          <a:solidFill>
-                            <a:srgbClr val="B54A1C"/>
-                          </a:solidFill>
-                        </a:rPr>
-                        <a:t>El cohete se estrellaba a los 388 s</a:t>
-                      </a:r>
-                      <a:endParaRPr lang="en-US" sz="1350" dirty="0"/>
-                    </a:p>
-                  </a:txBody>
-                  <a:tcPr marL="73152" marR="73152" marT="73152" marB="73152" anchor="ctr">
-                    <a:lnL w="6350" cap="flat" cmpd="sng" algn="ctr">
-                      <a:solidFill>
-                        <a:srgbClr val="D5DAE1"/>
-                      </a:solidFill>
-                      <a:prstDash val="solid"/>
-                      <a:round/>
-                      <a:headEnd type="none" w="med" len="med"/>
-                      <a:tailEnd type="none" w="med" len="med"/>
-                    </a:lnL>
-                    <a:lnR w="6350" cap="flat" cmpd="sng" algn="ctr">
-                      <a:solidFill>
-                        <a:srgbClr val="D5DAE1"/>
-                      </a:solidFill>
-                      <a:prstDash val="solid"/>
-                      <a:round/>
-                      <a:headEnd type="none" w="med" len="med"/>
-                      <a:tailEnd type="none" w="med" len="med"/>
-                    </a:lnR>
-                    <a:lnT w="6350" cap="flat" cmpd="sng" algn="ctr">
-                      <a:solidFill>
-                        <a:srgbClr val="D5DAE1"/>
-                      </a:solidFill>
-                      <a:prstDash val="solid"/>
-                      <a:round/>
-                      <a:headEnd type="none" w="med" len="med"/>
-                      <a:tailEnd type="none" w="med" len="med"/>
-                    </a:lnT>
-                    <a:lnB w="6350" cap="flat" cmpd="sng" algn="ctr">
-                      <a:solidFill>
-                        <a:srgbClr val="D5DAE1"/>
-                      </a:solidFill>
-                      <a:prstDash val="solid"/>
-                      <a:round/>
-                      <a:headEnd type="none" w="med" len="med"/>
-                      <a:tailEnd type="none" w="med" len="med"/>
-                    </a:lnB>
-                    <a:solidFill>
-                      <a:srgbClr val="EEF2F7"/>
-                    </a:solidFill>
-                  </a:tcPr>
-                </a:tc>
-                <a:tc>
-                  <a:txBody>
-                    <a:bodyPr/>
-                    <a:lstStyle/>
-                    <a:p>
-                      <a:pPr indent="0" marL="0">
-                        <a:buNone/>
-                      </a:pPr>
-                      <a:r>
-                        <a:rPr lang="en-US" sz="1350" dirty="0">
-                          <a:solidFill>
-                            <a:srgbClr val="137A55"/>
-                          </a:solidFill>
-                        </a:rPr>
-                        <a:t>Guiado de tangente lineal → MECO a 160 km</a:t>
-                      </a:r>
-                      <a:endParaRPr lang="en-US" sz="1350" dirty="0"/>
-                    </a:p>
-                  </a:txBody>
-                  <a:tcPr marL="73152" marR="73152" marT="73152" marB="73152" anchor="ctr">
-                    <a:lnL w="6350" cap="flat" cmpd="sng" algn="ctr">
-                      <a:solidFill>
-                        <a:srgbClr val="D5DAE1"/>
-                      </a:solidFill>
-                      <a:prstDash val="solid"/>
-                      <a:round/>
-                      <a:headEnd type="none" w="med" len="med"/>
-                      <a:tailEnd type="none" w="med" len="med"/>
-                    </a:lnL>
-                    <a:lnR w="6350" cap="flat" cmpd="sng" algn="ctr">
-                      <a:solidFill>
-                        <a:srgbClr val="D5DAE1"/>
-                      </a:solidFill>
-                      <a:prstDash val="solid"/>
-                      <a:round/>
-                      <a:headEnd type="none" w="med" len="med"/>
-                      <a:tailEnd type="none" w="med" len="med"/>
-                    </a:lnR>
-                    <a:lnT w="6350" cap="flat" cmpd="sng" algn="ctr">
-                      <a:solidFill>
-                        <a:srgbClr val="D5DAE1"/>
-                      </a:solidFill>
-                      <a:prstDash val="solid"/>
-                      <a:round/>
-                      <a:headEnd type="none" w="med" len="med"/>
-                      <a:tailEnd type="none" w="med" len="med"/>
-                    </a:lnT>
-                    <a:lnB w="6350" cap="flat" cmpd="sng" algn="ctr">
-                      <a:solidFill>
-                        <a:srgbClr val="D5DAE1"/>
-                      </a:solidFill>
-                      <a:prstDash val="solid"/>
-                      <a:round/>
-                      <a:headEnd type="none" w="med" len="med"/>
-                      <a:tailEnd type="none" w="med" len="med"/>
-                    </a:lnB>
-                    <a:solidFill>
-                      <a:srgbClr val="EEF2F7"/>
-                    </a:solidFill>
-                  </a:tcPr>
-                </a:tc>
-              </a:tr>
-              <a:tr h="475488">
-                <a:tc>
-                  <a:txBody>
-                    <a:bodyPr/>
-                    <a:lstStyle/>
-                    <a:p>
-                      <a:pPr indent="0" marL="0">
-                        <a:buNone/>
-                      </a:pPr>
-                      <a:r>
-                        <a:rPr lang="en-US" sz="1350" b="1" dirty="0">
-                          <a:solidFill>
-                            <a:srgbClr val="0B1D3A"/>
-                          </a:solidFill>
-                        </a:rPr>
-                        <a:t>Eventos</a:t>
-                      </a:r>
-                      <a:endParaRPr lang="en-US" sz="1350" dirty="0"/>
-                    </a:p>
-                  </a:txBody>
-                  <a:tcPr marL="73152" marR="73152" marT="73152" marB="73152" anchor="ctr">
-                    <a:lnL w="6350" cap="flat" cmpd="sng" algn="ctr">
-                      <a:solidFill>
-                        <a:srgbClr val="D5DAE1"/>
-                      </a:solidFill>
-                      <a:prstDash val="solid"/>
-                      <a:round/>
-                      <a:headEnd type="none" w="med" len="med"/>
-                      <a:tailEnd type="none" w="med" len="med"/>
-                    </a:lnL>
-                    <a:lnR w="6350" cap="flat" cmpd="sng" algn="ctr">
-                      <a:solidFill>
-                        <a:srgbClr val="D5DAE1"/>
-                      </a:solidFill>
-                      <a:prstDash val="solid"/>
-                      <a:round/>
-                      <a:headEnd type="none" w="med" len="med"/>
-                      <a:tailEnd type="none" w="med" len="med"/>
-                    </a:lnR>
-                    <a:lnT w="6350" cap="flat" cmpd="sng" algn="ctr">
-                      <a:solidFill>
-                        <a:srgbClr val="D5DAE1"/>
-                      </a:solidFill>
-                      <a:prstDash val="solid"/>
-                      <a:round/>
-                      <a:headEnd type="none" w="med" len="med"/>
-                      <a:tailEnd type="none" w="med" len="med"/>
-                    </a:lnT>
-                    <a:lnB w="6350" cap="flat" cmpd="sng" algn="ctr">
-                      <a:solidFill>
-                        <a:srgbClr val="D5DAE1"/>
-                      </a:solidFill>
-                      <a:prstDash val="solid"/>
-                      <a:round/>
-                      <a:headEnd type="none" w="med" len="med"/>
-                      <a:tailEnd type="none" w="med" len="med"/>
-                    </a:lnB>
-                    <a:solidFill>
-                      <a:srgbClr val="FFFFFF"/>
-                    </a:solidFill>
-                  </a:tcPr>
-                </a:tc>
-                <a:tc>
-                  <a:txBody>
-                    <a:bodyPr/>
-                    <a:lstStyle/>
-                    <a:p>
-                      <a:pPr indent="0" marL="0">
-                        <a:buNone/>
-                      </a:pPr>
-                      <a:r>
-                        <a:rPr lang="en-US" sz="1350" dirty="0">
-                          <a:solidFill>
-                            <a:srgbClr val="B54A1C"/>
-                          </a:solidFill>
-                        </a:rPr>
-                        <a:t>Constantes fijas (126 s, 180 t)</a:t>
-                      </a:r>
-                      <a:endParaRPr lang="en-US" sz="1350" dirty="0"/>
-                    </a:p>
-                  </a:txBody>
-                  <a:tcPr marL="73152" marR="73152" marT="73152" marB="73152" anchor="ctr">
-                    <a:lnL w="6350" cap="flat" cmpd="sng" algn="ctr">
-                      <a:solidFill>
-                        <a:srgbClr val="D5DAE1"/>
-                      </a:solidFill>
-                      <a:prstDash val="solid"/>
-                      <a:round/>
-                      <a:headEnd type="none" w="med" len="med"/>
-                      <a:tailEnd type="none" w="med" len="med"/>
-                    </a:lnL>
-                    <a:lnR w="6350" cap="flat" cmpd="sng" algn="ctr">
-                      <a:solidFill>
-                        <a:srgbClr val="D5DAE1"/>
-                      </a:solidFill>
-                      <a:prstDash val="solid"/>
-                      <a:round/>
-                      <a:headEnd type="none" w="med" len="med"/>
-                      <a:tailEnd type="none" w="med" len="med"/>
-                    </a:lnR>
-                    <a:lnT w="6350" cap="flat" cmpd="sng" algn="ctr">
-                      <a:solidFill>
-                        <a:srgbClr val="D5DAE1"/>
-                      </a:solidFill>
-                      <a:prstDash val="solid"/>
-                      <a:round/>
-                      <a:headEnd type="none" w="med" len="med"/>
-                      <a:tailEnd type="none" w="med" len="med"/>
-                    </a:lnT>
-                    <a:lnB w="6350" cap="flat" cmpd="sng" algn="ctr">
-                      <a:solidFill>
-                        <a:srgbClr val="D5DAE1"/>
-                      </a:solidFill>
-                      <a:prstDash val="solid"/>
-                      <a:round/>
-                      <a:headEnd type="none" w="med" len="med"/>
-                      <a:tailEnd type="none" w="med" len="med"/>
-                    </a:lnB>
-                    <a:solidFill>
-                      <a:srgbClr val="FFFFFF"/>
-                    </a:solidFill>
-                  </a:tcPr>
-                </a:tc>
-                <a:tc>
-                  <a:txBody>
-                    <a:bodyPr/>
-                    <a:lstStyle/>
-                    <a:p>
-                      <a:pPr indent="0" marL="0">
-                        <a:buNone/>
-                      </a:pPr>
-                      <a:r>
-                        <a:rPr lang="en-US" sz="1350" dirty="0">
-                          <a:solidFill>
-                            <a:srgbClr val="137A55"/>
-                          </a:solidFill>
-                        </a:rPr>
-                        <a:t>Fábricas basadas en AscentConfig</a:t>
-                      </a:r>
-                      <a:endParaRPr lang="en-US" sz="1350" dirty="0"/>
-                    </a:p>
-                  </a:txBody>
-                  <a:tcPr marL="73152" marR="73152" marT="73152" marB="73152" anchor="ctr">
-                    <a:lnL w="6350" cap="flat" cmpd="sng" algn="ctr">
-                      <a:solidFill>
-                        <a:srgbClr val="D5DAE1"/>
-                      </a:solidFill>
-                      <a:prstDash val="solid"/>
-                      <a:round/>
-                      <a:headEnd type="none" w="med" len="med"/>
-                      <a:tailEnd type="none" w="med" len="med"/>
-                    </a:lnL>
-                    <a:lnR w="6350" cap="flat" cmpd="sng" algn="ctr">
-                      <a:solidFill>
-                        <a:srgbClr val="D5DAE1"/>
-                      </a:solidFill>
-                      <a:prstDash val="solid"/>
-                      <a:round/>
-                      <a:headEnd type="none" w="med" len="med"/>
-                      <a:tailEnd type="none" w="med" len="med"/>
-                    </a:lnR>
-                    <a:lnT w="6350" cap="flat" cmpd="sng" algn="ctr">
-                      <a:solidFill>
-                        <a:srgbClr val="D5DAE1"/>
-                      </a:solidFill>
-                      <a:prstDash val="solid"/>
-                      <a:round/>
-                      <a:headEnd type="none" w="med" len="med"/>
-                      <a:tailEnd type="none" w="med" len="med"/>
-                    </a:lnT>
-                    <a:lnB w="6350" cap="flat" cmpd="sng" algn="ctr">
-                      <a:solidFill>
-                        <a:srgbClr val="D5DAE1"/>
-                      </a:solidFill>
-                      <a:prstDash val="solid"/>
-                      <a:round/>
-                      <a:headEnd type="none" w="med" len="med"/>
-                      <a:tailEnd type="none" w="med" len="med"/>
-                    </a:lnB>
-                    <a:solidFill>
-                      <a:srgbClr val="FFFFFF"/>
-                    </a:solidFill>
-                  </a:tcPr>
-                </a:tc>
-              </a:tr>
-              <a:tr h="475488">
-                <a:tc>
-                  <a:txBody>
-                    <a:bodyPr/>
-                    <a:lstStyle/>
-                    <a:p>
-                      <a:pPr indent="0" marL="0">
-                        <a:buNone/>
-                      </a:pPr>
-                      <a:r>
-                        <a:rPr lang="en-US" sz="1350" b="1" dirty="0">
-                          <a:solidFill>
-                            <a:srgbClr val="0B1D3A"/>
-                          </a:solidFill>
-                        </a:rPr>
-                        <a:t>Movimiento medio lunar</a:t>
-                      </a:r>
-                      <a:endParaRPr lang="en-US" sz="1350" dirty="0"/>
-                    </a:p>
-                  </a:txBody>
-                  <a:tcPr marL="73152" marR="73152" marT="73152" marB="73152" anchor="ctr">
-                    <a:lnL w="6350" cap="flat" cmpd="sng" algn="ctr">
-                      <a:solidFill>
-                        <a:srgbClr val="D5DAE1"/>
-                      </a:solidFill>
-                      <a:prstDash val="solid"/>
-                      <a:round/>
-                      <a:headEnd type="none" w="med" len="med"/>
-                      <a:tailEnd type="none" w="med" len="med"/>
-                    </a:lnL>
-                    <a:lnR w="6350" cap="flat" cmpd="sng" algn="ctr">
-                      <a:solidFill>
-                        <a:srgbClr val="D5DAE1"/>
-                      </a:solidFill>
-                      <a:prstDash val="solid"/>
-                      <a:round/>
-                      <a:headEnd type="none" w="med" len="med"/>
-                      <a:tailEnd type="none" w="med" len="med"/>
-                    </a:lnR>
-                    <a:lnT w="6350" cap="flat" cmpd="sng" algn="ctr">
-                      <a:solidFill>
-                        <a:srgbClr val="D5DAE1"/>
-                      </a:solidFill>
-                      <a:prstDash val="solid"/>
-                      <a:round/>
-                      <a:headEnd type="none" w="med" len="med"/>
-                      <a:tailEnd type="none" w="med" len="med"/>
-                    </a:lnT>
-                    <a:lnB w="6350" cap="flat" cmpd="sng" algn="ctr">
-                      <a:solidFill>
-                        <a:srgbClr val="D5DAE1"/>
-                      </a:solidFill>
-                      <a:prstDash val="solid"/>
-                      <a:round/>
-                      <a:headEnd type="none" w="med" len="med"/>
-                      <a:tailEnd type="none" w="med" len="med"/>
-                    </a:lnB>
-                    <a:solidFill>
-                      <a:srgbClr val="EEF2F7"/>
-                    </a:solidFill>
-                  </a:tcPr>
-                </a:tc>
-                <a:tc>
-                  <a:txBody>
-                    <a:bodyPr/>
-                    <a:lstStyle/>
-                    <a:p>
-                      <a:pPr indent="0" marL="0">
-                        <a:buNone/>
-                      </a:pPr>
-                      <a:r>
-                        <a:rPr lang="en-US" sz="1350" dirty="0">
-                          <a:solidFill>
-                            <a:srgbClr val="B54A1C"/>
-                          </a:solidFill>
-                        </a:rPr>
-                        <a:t>Inconsistente con μ_E + μ_L</a:t>
-                      </a:r>
-                      <a:endParaRPr lang="en-US" sz="1350" dirty="0"/>
-                    </a:p>
-                  </a:txBody>
-                  <a:tcPr marL="73152" marR="73152" marT="73152" marB="73152" anchor="ctr">
-                    <a:lnL w="6350" cap="flat" cmpd="sng" algn="ctr">
-                      <a:solidFill>
-                        <a:srgbClr val="D5DAE1"/>
-                      </a:solidFill>
-                      <a:prstDash val="solid"/>
-                      <a:round/>
-                      <a:headEnd type="none" w="med" len="med"/>
-                      <a:tailEnd type="none" w="med" len="med"/>
-                    </a:lnL>
-                    <a:lnR w="6350" cap="flat" cmpd="sng" algn="ctr">
-                      <a:solidFill>
-                        <a:srgbClr val="D5DAE1"/>
-                      </a:solidFill>
-                      <a:prstDash val="solid"/>
-                      <a:round/>
-                      <a:headEnd type="none" w="med" len="med"/>
-                      <a:tailEnd type="none" w="med" len="med"/>
-                    </a:lnR>
-                    <a:lnT w="6350" cap="flat" cmpd="sng" algn="ctr">
-                      <a:solidFill>
-                        <a:srgbClr val="D5DAE1"/>
-                      </a:solidFill>
-                      <a:prstDash val="solid"/>
-                      <a:round/>
-                      <a:headEnd type="none" w="med" len="med"/>
-                      <a:tailEnd type="none" w="med" len="med"/>
-                    </a:lnT>
-                    <a:lnB w="6350" cap="flat" cmpd="sng" algn="ctr">
-                      <a:solidFill>
-                        <a:srgbClr val="D5DAE1"/>
-                      </a:solidFill>
-                      <a:prstDash val="solid"/>
-                      <a:round/>
-                      <a:headEnd type="none" w="med" len="med"/>
-                      <a:tailEnd type="none" w="med" len="med"/>
-                    </a:lnB>
-                    <a:solidFill>
-                      <a:srgbClr val="EEF2F7"/>
-                    </a:solidFill>
-                  </a:tcPr>
-                </a:tc>
-                <a:tc>
-                  <a:txBody>
-                    <a:bodyPr/>
-                    <a:lstStyle/>
-                    <a:p>
-                      <a:pPr indent="0" marL="0">
-                        <a:buNone/>
-                      </a:pPr>
-                      <a:r>
-                        <a:rPr lang="en-US" sz="1350" dirty="0">
-                          <a:solidFill>
-                            <a:srgbClr val="137A55"/>
-                          </a:solidFill>
-                        </a:rPr>
-                        <a:t>n = √((μ_E+μ_L)/d³)</a:t>
-                      </a:r>
-                      <a:endParaRPr lang="en-US" sz="1350" dirty="0"/>
-                    </a:p>
-                  </a:txBody>
-                  <a:tcPr marL="73152" marR="73152" marT="73152" marB="73152" anchor="ctr">
-                    <a:lnL w="6350" cap="flat" cmpd="sng" algn="ctr">
-                      <a:solidFill>
-                        <a:srgbClr val="D5DAE1"/>
-                      </a:solidFill>
-                      <a:prstDash val="solid"/>
-                      <a:round/>
-                      <a:headEnd type="none" w="med" len="med"/>
-                      <a:tailEnd type="none" w="med" len="med"/>
-                    </a:lnL>
-                    <a:lnR w="6350" cap="flat" cmpd="sng" algn="ctr">
-                      <a:solidFill>
-                        <a:srgbClr val="D5DAE1"/>
-                      </a:solidFill>
-                      <a:prstDash val="solid"/>
-                      <a:round/>
-                      <a:headEnd type="none" w="med" len="med"/>
-                      <a:tailEnd type="none" w="med" len="med"/>
-                    </a:lnR>
-                    <a:lnT w="6350" cap="flat" cmpd="sng" algn="ctr">
-                      <a:solidFill>
-                        <a:srgbClr val="D5DAE1"/>
-                      </a:solidFill>
-                      <a:prstDash val="solid"/>
-                      <a:round/>
-                      <a:headEnd type="none" w="med" len="med"/>
-                      <a:tailEnd type="none" w="med" len="med"/>
-                    </a:lnT>
-                    <a:lnB w="6350" cap="flat" cmpd="sng" algn="ctr">
-                      <a:solidFill>
-                        <a:srgbClr val="D5DAE1"/>
-                      </a:solidFill>
-                      <a:prstDash val="solid"/>
-                      <a:round/>
-                      <a:headEnd type="none" w="med" len="med"/>
-                      <a:tailEnd type="none" w="med" len="med"/>
-                    </a:lnB>
-                    <a:solidFill>
-                      <a:srgbClr val="EEF2F7"/>
-                    </a:solidFill>
-                  </a:tcPr>
-                </a:tc>
-              </a:tr>
-              <a:tr h="475488">
-                <a:tc>
-                  <a:txBody>
-                    <a:bodyPr/>
-                    <a:lstStyle/>
-                    <a:p>
-                      <a:pPr indent="0" marL="0">
-                        <a:buNone/>
-                      </a:pPr>
-                      <a:r>
-                        <a:rPr lang="en-US" sz="1350" b="1" dirty="0">
-                          <a:solidFill>
-                            <a:srgbClr val="0B1D3A"/>
-                          </a:solidFill>
-                        </a:rPr>
-                        <a:t>Diagnóstico energético</a:t>
-                      </a:r>
-                      <a:endParaRPr lang="en-US" sz="1350" dirty="0"/>
-                    </a:p>
-                  </a:txBody>
-                  <a:tcPr marL="73152" marR="73152" marT="73152" marB="73152" anchor="ctr">
-                    <a:lnL w="6350" cap="flat" cmpd="sng" algn="ctr">
-                      <a:solidFill>
-                        <a:srgbClr val="D5DAE1"/>
-                      </a:solidFill>
-                      <a:prstDash val="solid"/>
-                      <a:round/>
-                      <a:headEnd type="none" w="med" len="med"/>
-                      <a:tailEnd type="none" w="med" len="med"/>
-                    </a:lnL>
-                    <a:lnR w="6350" cap="flat" cmpd="sng" algn="ctr">
-                      <a:solidFill>
-                        <a:srgbClr val="D5DAE1"/>
-                      </a:solidFill>
-                      <a:prstDash val="solid"/>
-                      <a:round/>
-                      <a:headEnd type="none" w="med" len="med"/>
-                      <a:tailEnd type="none" w="med" len="med"/>
-                    </a:lnR>
-                    <a:lnT w="6350" cap="flat" cmpd="sng" algn="ctr">
-                      <a:solidFill>
-                        <a:srgbClr val="D5DAE1"/>
-                      </a:solidFill>
-                      <a:prstDash val="solid"/>
-                      <a:round/>
-                      <a:headEnd type="none" w="med" len="med"/>
-                      <a:tailEnd type="none" w="med" len="med"/>
-                    </a:lnT>
-                    <a:lnB w="6350" cap="flat" cmpd="sng" algn="ctr">
-                      <a:solidFill>
-                        <a:srgbClr val="D5DAE1"/>
-                      </a:solidFill>
-                      <a:prstDash val="solid"/>
-                      <a:round/>
-                      <a:headEnd type="none" w="med" len="med"/>
-                      <a:tailEnd type="none" w="med" len="med"/>
-                    </a:lnB>
-                    <a:solidFill>
-                      <a:srgbClr val="FFFFFF"/>
-                    </a:solidFill>
-                  </a:tcPr>
-                </a:tc>
-                <a:tc>
-                  <a:txBody>
-                    <a:bodyPr/>
-                    <a:lstStyle/>
-                    <a:p>
-                      <a:pPr indent="0" marL="0">
-                        <a:buNone/>
-                      </a:pPr>
-                      <a:r>
-                        <a:rPr lang="en-US" sz="1350" dirty="0">
-                          <a:solidFill>
-                            <a:srgbClr val="B54A1C"/>
-                          </a:solidFill>
-                        </a:rPr>
-                        <a:t>Energía geocéntrica no conservada</a:t>
-                      </a:r>
-                      <a:endParaRPr lang="en-US" sz="1350" dirty="0"/>
-                    </a:p>
-                  </a:txBody>
-                  <a:tcPr marL="73152" marR="73152" marT="73152" marB="73152" anchor="ctr">
-                    <a:lnL w="6350" cap="flat" cmpd="sng" algn="ctr">
-                      <a:solidFill>
-                        <a:srgbClr val="D5DAE1"/>
-                      </a:solidFill>
-                      <a:prstDash val="solid"/>
-                      <a:round/>
-                      <a:headEnd type="none" w="med" len="med"/>
-                      <a:tailEnd type="none" w="med" len="med"/>
-                    </a:lnL>
-                    <a:lnR w="6350" cap="flat" cmpd="sng" algn="ctr">
-                      <a:solidFill>
-                        <a:srgbClr val="D5DAE1"/>
-                      </a:solidFill>
-                      <a:prstDash val="solid"/>
-                      <a:round/>
-                      <a:headEnd type="none" w="med" len="med"/>
-                      <a:tailEnd type="none" w="med" len="med"/>
-                    </a:lnR>
-                    <a:lnT w="6350" cap="flat" cmpd="sng" algn="ctr">
-                      <a:solidFill>
-                        <a:srgbClr val="D5DAE1"/>
-                      </a:solidFill>
-                      <a:prstDash val="solid"/>
-                      <a:round/>
-                      <a:headEnd type="none" w="med" len="med"/>
-                      <a:tailEnd type="none" w="med" len="med"/>
-                    </a:lnT>
-                    <a:lnB w="6350" cap="flat" cmpd="sng" algn="ctr">
-                      <a:solidFill>
-                        <a:srgbClr val="D5DAE1"/>
-                      </a:solidFill>
-                      <a:prstDash val="solid"/>
-                      <a:round/>
-                      <a:headEnd type="none" w="med" len="med"/>
-                      <a:tailEnd type="none" w="med" len="med"/>
-                    </a:lnB>
-                    <a:solidFill>
-                      <a:srgbClr val="FFFFFF"/>
-                    </a:solidFill>
-                  </a:tcPr>
-                </a:tc>
-                <a:tc>
-                  <a:txBody>
-                    <a:bodyPr/>
-                    <a:lstStyle/>
-                    <a:p>
-                      <a:pPr indent="0" marL="0">
-                        <a:buNone/>
-                      </a:pPr>
-                      <a:r>
-                        <a:rPr lang="en-US" sz="1350" dirty="0">
-                          <a:solidFill>
-                            <a:srgbClr val="137A55"/>
-                          </a:solidFill>
-                        </a:rPr>
-                        <a:t>Integral de Jacobi</a:t>
-                      </a:r>
-                      <a:endParaRPr lang="en-US" sz="1350" dirty="0"/>
-                    </a:p>
-                  </a:txBody>
-                  <a:tcPr marL="73152" marR="73152" marT="73152" marB="73152" anchor="ctr">
-                    <a:lnL w="6350" cap="flat" cmpd="sng" algn="ctr">
-                      <a:solidFill>
-                        <a:srgbClr val="D5DAE1"/>
-                      </a:solidFill>
-                      <a:prstDash val="solid"/>
-                      <a:round/>
-                      <a:headEnd type="none" w="med" len="med"/>
-                      <a:tailEnd type="none" w="med" len="med"/>
-                    </a:lnL>
-                    <a:lnR w="6350" cap="flat" cmpd="sng" algn="ctr">
-                      <a:solidFill>
-                        <a:srgbClr val="D5DAE1"/>
-                      </a:solidFill>
-                      <a:prstDash val="solid"/>
-                      <a:round/>
-                      <a:headEnd type="none" w="med" len="med"/>
-                      <a:tailEnd type="none" w="med" len="med"/>
-                    </a:lnR>
-                    <a:lnT w="6350" cap="flat" cmpd="sng" algn="ctr">
-                      <a:solidFill>
-                        <a:srgbClr val="D5DAE1"/>
-                      </a:solidFill>
-                      <a:prstDash val="solid"/>
-                      <a:round/>
-                      <a:headEnd type="none" w="med" len="med"/>
-                      <a:tailEnd type="none" w="med" len="med"/>
-                    </a:lnT>
-                    <a:lnB w="6350" cap="flat" cmpd="sng" algn="ctr">
-                      <a:solidFill>
-                        <a:srgbClr val="D5DAE1"/>
-                      </a:solidFill>
-                      <a:prstDash val="solid"/>
-                      <a:round/>
-                      <a:headEnd type="none" w="med" len="med"/>
-                      <a:tailEnd type="none" w="med" len="med"/>
-                    </a:lnB>
-                    <a:solidFill>
-                      <a:srgbClr val="FFFFFF"/>
-                    </a:solidFill>
-                  </a:tcPr>
-                </a:tc>
-              </a:tr>
-              <a:tr h="475488">
-                <a:tc>
-                  <a:txBody>
-                    <a:bodyPr/>
-                    <a:lstStyle/>
-                    <a:p>
-                      <a:pPr indent="0" marL="0">
-                        <a:buNone/>
-                      </a:pPr>
-                      <a:r>
-                        <a:rPr lang="en-US" sz="1350" b="1" dirty="0">
-                          <a:solidFill>
-                            <a:srgbClr val="0B1D3A"/>
-                          </a:solidFill>
-                        </a:rPr>
-                        <a:t>Targeting TLI</a:t>
-                      </a:r>
-                      <a:endParaRPr lang="en-US" sz="1350" dirty="0"/>
-                    </a:p>
-                  </a:txBody>
-                  <a:tcPr marL="73152" marR="73152" marT="73152" marB="73152" anchor="ctr">
-                    <a:lnL w="6350" cap="flat" cmpd="sng" algn="ctr">
-                      <a:solidFill>
-                        <a:srgbClr val="D5DAE1"/>
-                      </a:solidFill>
-                      <a:prstDash val="solid"/>
-                      <a:round/>
-                      <a:headEnd type="none" w="med" len="med"/>
-                      <a:tailEnd type="none" w="med" len="med"/>
-                    </a:lnL>
-                    <a:lnR w="6350" cap="flat" cmpd="sng" algn="ctr">
-                      <a:solidFill>
-                        <a:srgbClr val="D5DAE1"/>
-                      </a:solidFill>
-                      <a:prstDash val="solid"/>
-                      <a:round/>
-                      <a:headEnd type="none" w="med" len="med"/>
-                      <a:tailEnd type="none" w="med" len="med"/>
-                    </a:lnR>
-                    <a:lnT w="6350" cap="flat" cmpd="sng" algn="ctr">
-                      <a:solidFill>
-                        <a:srgbClr val="D5DAE1"/>
-                      </a:solidFill>
-                      <a:prstDash val="solid"/>
-                      <a:round/>
-                      <a:headEnd type="none" w="med" len="med"/>
-                      <a:tailEnd type="none" w="med" len="med"/>
-                    </a:lnT>
-                    <a:lnB w="6350" cap="flat" cmpd="sng" algn="ctr">
-                      <a:solidFill>
-                        <a:srgbClr val="D5DAE1"/>
-                      </a:solidFill>
-                      <a:prstDash val="solid"/>
-                      <a:round/>
-                      <a:headEnd type="none" w="med" len="med"/>
-                      <a:tailEnd type="none" w="med" len="med"/>
-                    </a:lnB>
-                    <a:solidFill>
-                      <a:srgbClr val="EEF2F7"/>
-                    </a:solidFill>
-                  </a:tcPr>
-                </a:tc>
-                <a:tc>
-                  <a:txBody>
-                    <a:bodyPr/>
-                    <a:lstStyle/>
-                    <a:p>
-                      <a:pPr indent="0" marL="0">
-                        <a:buNone/>
-                      </a:pPr>
-                      <a:r>
-                        <a:rPr lang="en-US" sz="1350" dirty="0">
-                          <a:solidFill>
-                            <a:srgbClr val="B54A1C"/>
-                          </a:solidFill>
-                        </a:rPr>
-                        <a:t>No convergía (677 000 km)</a:t>
-                      </a:r>
-                      <a:endParaRPr lang="en-US" sz="1350" dirty="0"/>
-                    </a:p>
-                  </a:txBody>
-                  <a:tcPr marL="73152" marR="73152" marT="73152" marB="73152" anchor="ctr">
-                    <a:lnL w="6350" cap="flat" cmpd="sng" algn="ctr">
-                      <a:solidFill>
-                        <a:srgbClr val="D5DAE1"/>
-                      </a:solidFill>
-                      <a:prstDash val="solid"/>
-                      <a:round/>
-                      <a:headEnd type="none" w="med" len="med"/>
-                      <a:tailEnd type="none" w="med" len="med"/>
-                    </a:lnL>
-                    <a:lnR w="6350" cap="flat" cmpd="sng" algn="ctr">
-                      <a:solidFill>
-                        <a:srgbClr val="D5DAE1"/>
-                      </a:solidFill>
-                      <a:prstDash val="solid"/>
-                      <a:round/>
-                      <a:headEnd type="none" w="med" len="med"/>
-                      <a:tailEnd type="none" w="med" len="med"/>
-                    </a:lnR>
-                    <a:lnT w="6350" cap="flat" cmpd="sng" algn="ctr">
-                      <a:solidFill>
-                        <a:srgbClr val="D5DAE1"/>
-                      </a:solidFill>
-                      <a:prstDash val="solid"/>
-                      <a:round/>
-                      <a:headEnd type="none" w="med" len="med"/>
-                      <a:tailEnd type="none" w="med" len="med"/>
-                    </a:lnT>
-                    <a:lnB w="6350" cap="flat" cmpd="sng" algn="ctr">
-                      <a:solidFill>
-                        <a:srgbClr val="D5DAE1"/>
-                      </a:solidFill>
-                      <a:prstDash val="solid"/>
-                      <a:round/>
-                      <a:headEnd type="none" w="med" len="med"/>
-                      <a:tailEnd type="none" w="med" len="med"/>
-                    </a:lnB>
-                    <a:solidFill>
-                      <a:srgbClr val="EEF2F7"/>
-                    </a:solidFill>
-                  </a:tcPr>
-                </a:tc>
-                <a:tc>
-                  <a:txBody>
-                    <a:bodyPr/>
-                    <a:lstStyle/>
-                    <a:p>
-                      <a:pPr indent="0" marL="0">
-                        <a:buNone/>
-                      </a:pPr>
-                      <a:r>
-                        <a:rPr lang="en-US" sz="1350" dirty="0">
-                          <a:solidFill>
-                            <a:srgbClr val="137A55"/>
-                          </a:solidFill>
-                        </a:rPr>
-                        <a:t>Semilla de Kepler: 5 iteraciones</a:t>
-                      </a:r>
-                      <a:endParaRPr lang="en-US" sz="1350" dirty="0"/>
-                    </a:p>
-                  </a:txBody>
-                  <a:tcPr marL="73152" marR="73152" marT="73152" marB="73152" anchor="ctr">
-                    <a:lnL w="6350" cap="flat" cmpd="sng" algn="ctr">
-                      <a:solidFill>
-                        <a:srgbClr val="D5DAE1"/>
-                      </a:solidFill>
-                      <a:prstDash val="solid"/>
-                      <a:round/>
-                      <a:headEnd type="none" w="med" len="med"/>
-                      <a:tailEnd type="none" w="med" len="med"/>
-                    </a:lnL>
-                    <a:lnR w="6350" cap="flat" cmpd="sng" algn="ctr">
-                      <a:solidFill>
-                        <a:srgbClr val="D5DAE1"/>
-                      </a:solidFill>
-                      <a:prstDash val="solid"/>
-                      <a:round/>
-                      <a:headEnd type="none" w="med" len="med"/>
-                      <a:tailEnd type="none" w="med" len="med"/>
-                    </a:lnR>
-                    <a:lnT w="6350" cap="flat" cmpd="sng" algn="ctr">
-                      <a:solidFill>
-                        <a:srgbClr val="D5DAE1"/>
-                      </a:solidFill>
-                      <a:prstDash val="solid"/>
-                      <a:round/>
-                      <a:headEnd type="none" w="med" len="med"/>
-                      <a:tailEnd type="none" w="med" len="med"/>
-                    </a:lnT>
-                    <a:lnB w="6350" cap="flat" cmpd="sng" algn="ctr">
-                      <a:solidFill>
-                        <a:srgbClr val="D5DAE1"/>
-                      </a:solidFill>
-                      <a:prstDash val="solid"/>
-                      <a:round/>
-                      <a:headEnd type="none" w="med" len="med"/>
-                      <a:tailEnd type="none" w="med" len="med"/>
-                    </a:lnB>
-                    <a:solidFill>
-                      <a:srgbClr val="EEF2F7"/>
-                    </a:solidFill>
-                  </a:tcPr>
-                </a:tc>
-              </a:tr>
-              <a:tr h="475488">
-                <a:tc>
-                  <a:txBody>
-                    <a:bodyPr/>
-                    <a:lstStyle/>
-                    <a:p>
-                      <a:pPr indent="0" marL="0">
-                        <a:buNone/>
-                      </a:pPr>
-                      <a:r>
-                        <a:rPr lang="en-US" sz="1350" b="1" dirty="0">
-                          <a:solidFill>
-                            <a:srgbClr val="0B1D3A"/>
-                          </a:solidFill>
-                        </a:rPr>
-                        <a:t>Documento</a:t>
-                      </a:r>
-                      <a:endParaRPr lang="en-US" sz="1350" dirty="0"/>
-                    </a:p>
-                  </a:txBody>
-                  <a:tcPr marL="73152" marR="73152" marT="73152" marB="73152" anchor="ctr">
-                    <a:lnL w="6350" cap="flat" cmpd="sng" algn="ctr">
-                      <a:solidFill>
-                        <a:srgbClr val="D5DAE1"/>
-                      </a:solidFill>
-                      <a:prstDash val="solid"/>
-                      <a:round/>
-                      <a:headEnd type="none" w="med" len="med"/>
-                      <a:tailEnd type="none" w="med" len="med"/>
-                    </a:lnL>
-                    <a:lnR w="6350" cap="flat" cmpd="sng" algn="ctr">
-                      <a:solidFill>
-                        <a:srgbClr val="D5DAE1"/>
-                      </a:solidFill>
-                      <a:prstDash val="solid"/>
-                      <a:round/>
-                      <a:headEnd type="none" w="med" len="med"/>
-                      <a:tailEnd type="none" w="med" len="med"/>
-                    </a:lnR>
-                    <a:lnT w="6350" cap="flat" cmpd="sng" algn="ctr">
-                      <a:solidFill>
-                        <a:srgbClr val="D5DAE1"/>
-                      </a:solidFill>
-                      <a:prstDash val="solid"/>
-                      <a:round/>
-                      <a:headEnd type="none" w="med" len="med"/>
-                      <a:tailEnd type="none" w="med" len="med"/>
-                    </a:lnT>
-                    <a:lnB w="6350" cap="flat" cmpd="sng" algn="ctr">
-                      <a:solidFill>
-                        <a:srgbClr val="D5DAE1"/>
-                      </a:solidFill>
-                      <a:prstDash val="solid"/>
-                      <a:round/>
-                      <a:headEnd type="none" w="med" len="med"/>
-                      <a:tailEnd type="none" w="med" len="med"/>
-                    </a:lnB>
-                    <a:solidFill>
-                      <a:srgbClr val="FFFFFF"/>
-                    </a:solidFill>
-                  </a:tcPr>
-                </a:tc>
-                <a:tc>
-                  <a:txBody>
-                    <a:bodyPr/>
-                    <a:lstStyle/>
-                    <a:p>
-                      <a:pPr indent="0" marL="0">
-                        <a:buNone/>
-                      </a:pPr>
-                      <a:r>
-                        <a:rPr lang="en-US" sz="1350" dirty="0">
-                          <a:solidFill>
-                            <a:srgbClr val="B54A1C"/>
-                          </a:solidFill>
-                        </a:rPr>
-                        <a:t>ECI/ECEF mezclados; RK45 'rígido'</a:t>
-                      </a:r>
-                      <a:endParaRPr lang="en-US" sz="1350" dirty="0"/>
-                    </a:p>
-                  </a:txBody>
-                  <a:tcPr marL="73152" marR="73152" marT="73152" marB="73152" anchor="ctr">
-                    <a:lnL w="6350" cap="flat" cmpd="sng" algn="ctr">
-                      <a:solidFill>
-                        <a:srgbClr val="D5DAE1"/>
-                      </a:solidFill>
-                      <a:prstDash val="solid"/>
-                      <a:round/>
-                      <a:headEnd type="none" w="med" len="med"/>
-                      <a:tailEnd type="none" w="med" len="med"/>
-                    </a:lnL>
-                    <a:lnR w="6350" cap="flat" cmpd="sng" algn="ctr">
-                      <a:solidFill>
-                        <a:srgbClr val="D5DAE1"/>
-                      </a:solidFill>
-                      <a:prstDash val="solid"/>
-                      <a:round/>
-                      <a:headEnd type="none" w="med" len="med"/>
-                      <a:tailEnd type="none" w="med" len="med"/>
-                    </a:lnR>
-                    <a:lnT w="6350" cap="flat" cmpd="sng" algn="ctr">
-                      <a:solidFill>
-                        <a:srgbClr val="D5DAE1"/>
-                      </a:solidFill>
-                      <a:prstDash val="solid"/>
-                      <a:round/>
-                      <a:headEnd type="none" w="med" len="med"/>
-                      <a:tailEnd type="none" w="med" len="med"/>
-                    </a:lnT>
-                    <a:lnB w="6350" cap="flat" cmpd="sng" algn="ctr">
-                      <a:solidFill>
-                        <a:srgbClr val="D5DAE1"/>
-                      </a:solidFill>
-                      <a:prstDash val="solid"/>
-                      <a:round/>
-                      <a:headEnd type="none" w="med" len="med"/>
-                      <a:tailEnd type="none" w="med" len="med"/>
-                    </a:lnB>
-                    <a:solidFill>
-                      <a:srgbClr val="FFFFFF"/>
-                    </a:solidFill>
-                  </a:tcPr>
-                </a:tc>
-                <a:tc>
-                  <a:txBody>
-                    <a:bodyPr/>
-                    <a:lstStyle/>
-                    <a:p>
-                      <a:pPr indent="0" marL="0">
-                        <a:buNone/>
-                      </a:pPr>
-                      <a:r>
-                        <a:rPr lang="en-US" sz="1350" dirty="0">
-                          <a:solidFill>
-                            <a:srgbClr val="137A55"/>
-                          </a:solidFill>
-                        </a:rPr>
-                        <a:t>Formulación corregida</a:t>
-                      </a:r>
-                      <a:endParaRPr lang="en-US" sz="1350" dirty="0"/>
-                    </a:p>
-                  </a:txBody>
-                  <a:tcPr marL="73152" marR="73152" marT="73152" marB="73152" anchor="ctr">
-                    <a:lnL w="6350" cap="flat" cmpd="sng" algn="ctr">
-                      <a:solidFill>
-                        <a:srgbClr val="D5DAE1"/>
-                      </a:solidFill>
-                      <a:prstDash val="solid"/>
-                      <a:round/>
-                      <a:headEnd type="none" w="med" len="med"/>
-                      <a:tailEnd type="none" w="med" len="med"/>
-                    </a:lnL>
-                    <a:lnR w="6350" cap="flat" cmpd="sng" algn="ctr">
-                      <a:solidFill>
-                        <a:srgbClr val="D5DAE1"/>
-                      </a:solidFill>
-                      <a:prstDash val="solid"/>
-                      <a:round/>
-                      <a:headEnd type="none" w="med" len="med"/>
-                      <a:tailEnd type="none" w="med" len="med"/>
-                    </a:lnR>
-                    <a:lnT w="6350" cap="flat" cmpd="sng" algn="ctr">
-                      <a:solidFill>
-                        <a:srgbClr val="D5DAE1"/>
-                      </a:solidFill>
-                      <a:prstDash val="solid"/>
-                      <a:round/>
-                      <a:headEnd type="none" w="med" len="med"/>
-                      <a:tailEnd type="none" w="med" len="med"/>
-                    </a:lnT>
-                    <a:lnB w="6350" cap="flat" cmpd="sng" algn="ctr">
-                      <a:solidFill>
-                        <a:srgbClr val="D5DAE1"/>
-                      </a:solidFill>
-                      <a:prstDash val="solid"/>
-                      <a:round/>
-                      <a:headEnd type="none" w="med" len="med"/>
-                      <a:tailEnd type="none" w="med" len="med"/>
-                    </a:lnB>
-                    <a:solidFill>
-                      <a:srgbClr val="FFFFFF"/>
-                    </a:solidFill>
-                  </a:tcPr>
-                </a:tc>
-              </a:tr>
-            </a:tbl>
-          </a:graphicData>
-        </a:graphic>
-      </p:graphicFrame>
-      <p:sp>
-        <p:nvSpPr>
-          <p:cNvPr id="4" name="Text 1"/>
+      <p:sp>
+        <p:nvSpPr>
+          <p:cNvPr id="3" name="Shape 1"/>
+          <p:cNvSpPr/>
+          <p:nvPr/>
+        </p:nvSpPr>
+        <p:spPr>
+          <a:xfrm>
+            <a:off x="548640" y="1234440"/>
+            <a:ext cx="1737360" cy="914400"/>
+          </a:xfrm>
+          <a:prstGeom prst="roundRect">
+            <a:avLst>
+              <a:gd name="adj" fmla="val 8000"/>
+            </a:avLst>
+          </a:prstGeom>
+          <a:solidFill>
+            <a:srgbClr val="FDEBDD"/>
+          </a:solidFill>
+          <a:ln w="12700">
+            <a:solidFill>
+              <a:srgbClr val="FDEBDD"/>
+            </a:solidFill>
+            <a:prstDash val="solid"/>
+          </a:ln>
+        </p:spPr>
+      </p:sp>
+      <p:sp>
+        <p:nvSpPr>
+          <p:cNvPr id="4" name="Text 2"/>
           <p:cNvSpPr txBox="1"/>
           <p:nvPr/>
         </p:nvSpPr>
         <p:spPr>
           <a:xfrm>
-            <a:off x="548640" y="5257800"/>
-            <a:ext cx="10058400" cy="365760"/>
+            <a:off x="548640" y="1234440"/>
+            <a:ext cx="1737360" cy="914400"/>
           </a:xfrm>
           <a:prstGeom prst="rect">
             <a:avLst/>
@@ -12820,18 +11246,731 @@
           <a:bodyPr wrap="square" lIns="0" tIns="0" rIns="0" bIns="0" rtlCol="0" anchor="ctr"/>
           <a:lstStyle/>
           <a:p>
+            <a:pPr algn="ctr" indent="0" marL="0">
+              <a:buNone/>
+            </a:pPr>
+            <a:r>
+              <a:rPr lang="en-US" sz="1700" b="1" dirty="0">
+                <a:solidFill>
+                  <a:srgbClr val="E8702A"/>
+                </a:solidFill>
+                <a:latin typeface="Cambria" pitchFamily="34" charset="0"/>
+                <a:ea typeface="Cambria" pitchFamily="34" charset="-122"/>
+                <a:cs typeface="Cambria" pitchFamily="34" charset="-120"/>
+              </a:rPr>
+              <a:t>Realismo</a:t>
+            </a:r>
+            <a:endParaRPr lang="en-US" sz="1700" dirty="0"/>
+          </a:p>
+        </p:txBody>
+      </p:sp>
+      <p:sp>
+        <p:nvSpPr>
+          <p:cNvPr id="5" name="Text 3"/>
+          <p:cNvSpPr txBox="1"/>
+          <p:nvPr/>
+        </p:nvSpPr>
+        <p:spPr>
+          <a:xfrm>
+            <a:off x="2514600" y="1252728"/>
+            <a:ext cx="5120640" cy="384048"/>
+          </a:xfrm>
+          <a:prstGeom prst="rect">
+            <a:avLst/>
+          </a:prstGeom>
+          <a:noFill/>
+          <a:ln/>
+        </p:spPr>
+        <p:txBody>
+          <a:bodyPr wrap="square" lIns="0" tIns="0" rIns="0" bIns="0" rtlCol="0" anchor="ctr"/>
+          <a:lstStyle/>
+          <a:p>
             <a:pPr indent="0" marL="0">
               <a:buNone/>
             </a:pPr>
             <a:r>
-              <a:rPr lang="en-US" sz="1400" i="1" dirty="0">
-                <a:solidFill>
-                  <a:srgbClr val="52514E"/>
-                </a:solidFill>
-              </a:rPr>
-              <a:t>Cada corrección tiene una prueba automática en tests/test_physics_corrections.py</a:t>
+              <a:rPr lang="en-US" sz="1700" b="1" dirty="0">
+                <a:solidFill>
+                  <a:srgbClr val="0B1D3A"/>
+                </a:solidFill>
+              </a:rPr>
+              <a:t>El simulador reproduce el vuelo real</a:t>
+            </a:r>
+            <a:endParaRPr lang="en-US" sz="1700" dirty="0"/>
+          </a:p>
+        </p:txBody>
+      </p:sp>
+      <p:sp>
+        <p:nvSpPr>
+          <p:cNvPr id="6" name="Text 4"/>
+          <p:cNvSpPr txBox="1"/>
+          <p:nvPr/>
+        </p:nvSpPr>
+        <p:spPr>
+          <a:xfrm>
+            <a:off x="2514600" y="1636776"/>
+            <a:ext cx="5120640" cy="512064"/>
+          </a:xfrm>
+          <a:prstGeom prst="rect">
+            <a:avLst/>
+          </a:prstGeom>
+          <a:noFill/>
+          <a:ln/>
+        </p:spPr>
+        <p:txBody>
+          <a:bodyPr wrap="square" lIns="0" tIns="0" rIns="0" bIns="0" rtlCol="0" anchor="t"/>
+          <a:lstStyle/>
+          <a:p>
+            <a:pPr indent="0" marL="0">
+              <a:buNone/>
+            </a:pPr>
+            <a:r>
+              <a:rPr lang="en-US" sz="1400" dirty="0">
+                <a:solidFill>
+                  <a:srgbClr val="1B1B1F"/>
+                </a:solidFill>
+              </a:rPr>
+              <a:t>El ascenso y el viaje a la Luna dan valores del mismo orden que los del SLS y las misiones lunares.</a:t>
             </a:r>
             <a:endParaRPr lang="en-US" sz="1400" dirty="0"/>
+          </a:p>
+        </p:txBody>
+      </p:sp>
+      <p:sp>
+        <p:nvSpPr>
+          <p:cNvPr id="7" name="Shape 5"/>
+          <p:cNvSpPr/>
+          <p:nvPr/>
+        </p:nvSpPr>
+        <p:spPr>
+          <a:xfrm>
+            <a:off x="548640" y="2350008"/>
+            <a:ext cx="1737360" cy="914400"/>
+          </a:xfrm>
+          <a:prstGeom prst="roundRect">
+            <a:avLst>
+              <a:gd name="adj" fmla="val 8000"/>
+            </a:avLst>
+          </a:prstGeom>
+          <a:solidFill>
+            <a:srgbClr val="EEF2F7"/>
+          </a:solidFill>
+          <a:ln w="12700">
+            <a:solidFill>
+              <a:srgbClr val="EEF2F7"/>
+            </a:solidFill>
+            <a:prstDash val="solid"/>
+          </a:ln>
+        </p:spPr>
+      </p:sp>
+      <p:sp>
+        <p:nvSpPr>
+          <p:cNvPr id="8" name="Text 6"/>
+          <p:cNvSpPr txBox="1"/>
+          <p:nvPr/>
+        </p:nvSpPr>
+        <p:spPr>
+          <a:xfrm>
+            <a:off x="548640" y="2350008"/>
+            <a:ext cx="1737360" cy="914400"/>
+          </a:xfrm>
+          <a:prstGeom prst="rect">
+            <a:avLst/>
+          </a:prstGeom>
+          <a:noFill/>
+          <a:ln/>
+        </p:spPr>
+        <p:txBody>
+          <a:bodyPr wrap="square" lIns="0" tIns="0" rIns="0" bIns="0" rtlCol="0" anchor="ctr"/>
+          <a:lstStyle/>
+          <a:p>
+            <a:pPr algn="ctr" indent="0" marL="0">
+              <a:buNone/>
+            </a:pPr>
+            <a:r>
+              <a:rPr lang="en-US" sz="1700" b="1" dirty="0">
+                <a:solidFill>
+                  <a:srgbClr val="0B1D3A"/>
+                </a:solidFill>
+                <a:latin typeface="Cambria" pitchFamily="34" charset="0"/>
+                <a:ea typeface="Cambria" pitchFamily="34" charset="-122"/>
+                <a:cs typeface="Cambria" pitchFamily="34" charset="-120"/>
+              </a:rPr>
+              <a:t>Métodos</a:t>
+            </a:r>
+            <a:endParaRPr lang="en-US" sz="1700" dirty="0"/>
+          </a:p>
+        </p:txBody>
+      </p:sp>
+      <p:sp>
+        <p:nvSpPr>
+          <p:cNvPr id="9" name="Text 7"/>
+          <p:cNvSpPr txBox="1"/>
+          <p:nvPr/>
+        </p:nvSpPr>
+        <p:spPr>
+          <a:xfrm>
+            <a:off x="2514600" y="2368296"/>
+            <a:ext cx="5120640" cy="384048"/>
+          </a:xfrm>
+          <a:prstGeom prst="rect">
+            <a:avLst/>
+          </a:prstGeom>
+          <a:noFill/>
+          <a:ln/>
+        </p:spPr>
+        <p:txBody>
+          <a:bodyPr wrap="square" lIns="0" tIns="0" rIns="0" bIns="0" rtlCol="0" anchor="ctr"/>
+          <a:lstStyle/>
+          <a:p>
+            <a:pPr indent="0" marL="0">
+              <a:buNone/>
+            </a:pPr>
+            <a:r>
+              <a:rPr lang="en-US" sz="1700" b="1" dirty="0">
+                <a:solidFill>
+                  <a:srgbClr val="0B1D3A"/>
+                </a:solidFill>
+              </a:rPr>
+              <a:t>Cada fase necesita su propio método</a:t>
+            </a:r>
+            <a:endParaRPr lang="en-US" sz="1700" dirty="0"/>
+          </a:p>
+        </p:txBody>
+      </p:sp>
+      <p:sp>
+        <p:nvSpPr>
+          <p:cNvPr id="10" name="Text 8"/>
+          <p:cNvSpPr txBox="1"/>
+          <p:nvPr/>
+        </p:nvSpPr>
+        <p:spPr>
+          <a:xfrm>
+            <a:off x="2514600" y="2752344"/>
+            <a:ext cx="5120640" cy="512064"/>
+          </a:xfrm>
+          <a:prstGeom prst="rect">
+            <a:avLst/>
+          </a:prstGeom>
+          <a:noFill/>
+          <a:ln/>
+        </p:spPr>
+        <p:txBody>
+          <a:bodyPr wrap="square" lIns="0" tIns="0" rIns="0" bIns="0" rtlCol="0" anchor="t"/>
+          <a:lstStyle/>
+          <a:p>
+            <a:pPr indent="0" marL="0">
+              <a:buNone/>
+            </a:pPr>
+            <a:r>
+              <a:rPr lang="en-US" sz="1400" dirty="0">
+                <a:solidFill>
+                  <a:srgbClr val="1B1B1F"/>
+                </a:solidFill>
+              </a:rPr>
+              <a:t>La atmósfera pide un método adaptativo (RK45); el vacío, uno que respete la energía (Verlet).</a:t>
+            </a:r>
+            <a:endParaRPr lang="en-US" sz="1400" dirty="0"/>
+          </a:p>
+        </p:txBody>
+      </p:sp>
+      <p:sp>
+        <p:nvSpPr>
+          <p:cNvPr id="11" name="Shape 9"/>
+          <p:cNvSpPr/>
+          <p:nvPr/>
+        </p:nvSpPr>
+        <p:spPr>
+          <a:xfrm>
+            <a:off x="548640" y="3465576"/>
+            <a:ext cx="1737360" cy="914400"/>
+          </a:xfrm>
+          <a:prstGeom prst="roundRect">
+            <a:avLst>
+              <a:gd name="adj" fmla="val 8000"/>
+            </a:avLst>
+          </a:prstGeom>
+          <a:solidFill>
+            <a:srgbClr val="FDEBDD"/>
+          </a:solidFill>
+          <a:ln w="12700">
+            <a:solidFill>
+              <a:srgbClr val="FDEBDD"/>
+            </a:solidFill>
+            <a:prstDash val="solid"/>
+          </a:ln>
+        </p:spPr>
+      </p:sp>
+      <p:sp>
+        <p:nvSpPr>
+          <p:cNvPr id="12" name="Text 10"/>
+          <p:cNvSpPr txBox="1"/>
+          <p:nvPr/>
+        </p:nvSpPr>
+        <p:spPr>
+          <a:xfrm>
+            <a:off x="548640" y="3465576"/>
+            <a:ext cx="1737360" cy="914400"/>
+          </a:xfrm>
+          <a:prstGeom prst="rect">
+            <a:avLst/>
+          </a:prstGeom>
+          <a:noFill/>
+          <a:ln/>
+        </p:spPr>
+        <p:txBody>
+          <a:bodyPr wrap="square" lIns="0" tIns="0" rIns="0" bIns="0" rtlCol="0" anchor="ctr"/>
+          <a:lstStyle/>
+          <a:p>
+            <a:pPr algn="ctr" indent="0" marL="0">
+              <a:buNone/>
+            </a:pPr>
+            <a:r>
+              <a:rPr lang="en-US" sz="1700" b="1" dirty="0">
+                <a:solidFill>
+                  <a:srgbClr val="E8702A"/>
+                </a:solidFill>
+                <a:latin typeface="Cambria" pitchFamily="34" charset="0"/>
+                <a:ea typeface="Cambria" pitchFamily="34" charset="-122"/>
+                <a:cs typeface="Cambria" pitchFamily="34" charset="-120"/>
+              </a:rPr>
+              <a:t>Energía</a:t>
+            </a:r>
+            <a:endParaRPr lang="en-US" sz="1700" dirty="0"/>
+          </a:p>
+        </p:txBody>
+      </p:sp>
+      <p:sp>
+        <p:nvSpPr>
+          <p:cNvPr id="13" name="Text 11"/>
+          <p:cNvSpPr txBox="1"/>
+          <p:nvPr/>
+        </p:nvSpPr>
+        <p:spPr>
+          <a:xfrm>
+            <a:off x="2514600" y="3483864"/>
+            <a:ext cx="5120640" cy="384048"/>
+          </a:xfrm>
+          <a:prstGeom prst="rect">
+            <a:avLst/>
+          </a:prstGeom>
+          <a:noFill/>
+          <a:ln/>
+        </p:spPr>
+        <p:txBody>
+          <a:bodyPr wrap="square" lIns="0" tIns="0" rIns="0" bIns="0" rtlCol="0" anchor="ctr"/>
+          <a:lstStyle/>
+          <a:p>
+            <a:pPr indent="0" marL="0">
+              <a:buNone/>
+            </a:pPr>
+            <a:r>
+              <a:rPr lang="en-US" sz="1700" b="1" dirty="0">
+                <a:solidFill>
+                  <a:srgbClr val="0B1D3A"/>
+                </a:solidFill>
+              </a:rPr>
+              <a:t>Para viajes largos, el método simpléctico gana</a:t>
+            </a:r>
+            <a:endParaRPr lang="en-US" sz="1700" dirty="0"/>
+          </a:p>
+        </p:txBody>
+      </p:sp>
+      <p:sp>
+        <p:nvSpPr>
+          <p:cNvPr id="14" name="Text 12"/>
+          <p:cNvSpPr txBox="1"/>
+          <p:nvPr/>
+        </p:nvSpPr>
+        <p:spPr>
+          <a:xfrm>
+            <a:off x="2514600" y="3867912"/>
+            <a:ext cx="5120640" cy="512064"/>
+          </a:xfrm>
+          <a:prstGeom prst="rect">
+            <a:avLst/>
+          </a:prstGeom>
+          <a:noFill/>
+          <a:ln/>
+        </p:spPr>
+        <p:txBody>
+          <a:bodyPr wrap="square" lIns="0" tIns="0" rIns="0" bIns="0" rtlCol="0" anchor="t"/>
+          <a:lstStyle/>
+          <a:p>
+            <a:pPr indent="0" marL="0">
+              <a:buNone/>
+            </a:pPr>
+            <a:r>
+              <a:rPr lang="en-US" sz="1400" dirty="0">
+                <a:solidFill>
+                  <a:srgbClr val="1B1B1F"/>
+                </a:solidFill>
+              </a:rPr>
+              <a:t>Su error de energía no crece con el tiempo, mientras que el de RK4 se acumula.</a:t>
+            </a:r>
+            <a:endParaRPr lang="en-US" sz="1400" dirty="0"/>
+          </a:p>
+        </p:txBody>
+      </p:sp>
+      <p:sp>
+        <p:nvSpPr>
+          <p:cNvPr id="15" name="Shape 13"/>
+          <p:cNvSpPr/>
+          <p:nvPr/>
+        </p:nvSpPr>
+        <p:spPr>
+          <a:xfrm>
+            <a:off x="548640" y="4581144"/>
+            <a:ext cx="1737360" cy="914400"/>
+          </a:xfrm>
+          <a:prstGeom prst="roundRect">
+            <a:avLst>
+              <a:gd name="adj" fmla="val 8000"/>
+            </a:avLst>
+          </a:prstGeom>
+          <a:solidFill>
+            <a:srgbClr val="EEF2F7"/>
+          </a:solidFill>
+          <a:ln w="12700">
+            <a:solidFill>
+              <a:srgbClr val="EEF2F7"/>
+            </a:solidFill>
+            <a:prstDash val="solid"/>
+          </a:ln>
+        </p:spPr>
+      </p:sp>
+      <p:sp>
+        <p:nvSpPr>
+          <p:cNvPr id="16" name="Text 14"/>
+          <p:cNvSpPr txBox="1"/>
+          <p:nvPr/>
+        </p:nvSpPr>
+        <p:spPr>
+          <a:xfrm>
+            <a:off x="548640" y="4581144"/>
+            <a:ext cx="1737360" cy="914400"/>
+          </a:xfrm>
+          <a:prstGeom prst="rect">
+            <a:avLst/>
+          </a:prstGeom>
+          <a:noFill/>
+          <a:ln/>
+        </p:spPr>
+        <p:txBody>
+          <a:bodyPr wrap="square" lIns="0" tIns="0" rIns="0" bIns="0" rtlCol="0" anchor="ctr"/>
+          <a:lstStyle/>
+          <a:p>
+            <a:pPr algn="ctr" indent="0" marL="0">
+              <a:buNone/>
+            </a:pPr>
+            <a:r>
+              <a:rPr lang="en-US" sz="1700" b="1" dirty="0">
+                <a:solidFill>
+                  <a:srgbClr val="0B1D3A"/>
+                </a:solidFill>
+                <a:latin typeface="Cambria" pitchFamily="34" charset="0"/>
+                <a:ea typeface="Cambria" pitchFamily="34" charset="-122"/>
+                <a:cs typeface="Cambria" pitchFamily="34" charset="-120"/>
+              </a:rPr>
+              <a:t>Misión</a:t>
+            </a:r>
+            <a:endParaRPr lang="en-US" sz="1700" dirty="0"/>
+          </a:p>
+        </p:txBody>
+      </p:sp>
+      <p:sp>
+        <p:nvSpPr>
+          <p:cNvPr id="17" name="Text 15"/>
+          <p:cNvSpPr txBox="1"/>
+          <p:nvPr/>
+        </p:nvSpPr>
+        <p:spPr>
+          <a:xfrm>
+            <a:off x="2514600" y="4599432"/>
+            <a:ext cx="5120640" cy="384048"/>
+          </a:xfrm>
+          <a:prstGeom prst="rect">
+            <a:avLst/>
+          </a:prstGeom>
+          <a:noFill/>
+          <a:ln/>
+        </p:spPr>
+        <p:txBody>
+          <a:bodyPr wrap="square" lIns="0" tIns="0" rIns="0" bIns="0" rtlCol="0" anchor="ctr"/>
+          <a:lstStyle/>
+          <a:p>
+            <a:pPr indent="0" marL="0">
+              <a:buNone/>
+            </a:pPr>
+            <a:r>
+              <a:rPr lang="en-US" sz="1700" b="1" dirty="0">
+                <a:solidFill>
+                  <a:srgbClr val="0B1D3A"/>
+                </a:solidFill>
+              </a:rPr>
+              <a:t>Llegar a la Luna es factible</a:t>
+            </a:r>
+            <a:endParaRPr lang="en-US" sz="1700" dirty="0"/>
+          </a:p>
+        </p:txBody>
+      </p:sp>
+      <p:sp>
+        <p:nvSpPr>
+          <p:cNvPr id="18" name="Text 16"/>
+          <p:cNvSpPr txBox="1"/>
+          <p:nvPr/>
+        </p:nvSpPr>
+        <p:spPr>
+          <a:xfrm>
+            <a:off x="2514600" y="4983480"/>
+            <a:ext cx="5120640" cy="512064"/>
+          </a:xfrm>
+          <a:prstGeom prst="rect">
+            <a:avLst/>
+          </a:prstGeom>
+          <a:noFill/>
+          <a:ln/>
+        </p:spPr>
+        <p:txBody>
+          <a:bodyPr wrap="square" lIns="0" tIns="0" rIns="0" bIns="0" rtlCol="0" anchor="t"/>
+          <a:lstStyle/>
+          <a:p>
+            <a:pPr indent="0" marL="0">
+              <a:buNone/>
+            </a:pPr>
+            <a:r>
+              <a:rPr lang="en-US" sz="1400" dirty="0">
+                <a:solidFill>
+                  <a:srgbClr val="1B1B1F"/>
+                </a:solidFill>
+              </a:rPr>
+              <a:t>La etapa EUS tiene combustible suficiente para entrar en órbita y luego impulsar la nave hacia la Luna.</a:t>
+            </a:r>
+            <a:endParaRPr lang="en-US" sz="1400" dirty="0"/>
+          </a:p>
+        </p:txBody>
+      </p:sp>
+      <p:sp>
+        <p:nvSpPr>
+          <p:cNvPr id="19" name="Shape 17"/>
+          <p:cNvSpPr/>
+          <p:nvPr/>
+        </p:nvSpPr>
+        <p:spPr>
+          <a:xfrm>
+            <a:off x="7818120" y="1188720"/>
+            <a:ext cx="3794760" cy="4526280"/>
+          </a:xfrm>
+          <a:prstGeom prst="roundRect">
+            <a:avLst>
+              <a:gd name="adj" fmla="val 2410"/>
+            </a:avLst>
+          </a:prstGeom>
+          <a:solidFill>
+            <a:srgbClr val="0B1D3A"/>
+          </a:solidFill>
+          <a:ln w="12700">
+            <a:solidFill>
+              <a:srgbClr val="0B1D3A"/>
+            </a:solidFill>
+            <a:prstDash val="solid"/>
+          </a:ln>
+        </p:spPr>
+      </p:sp>
+      <p:sp>
+        <p:nvSpPr>
+          <p:cNvPr id="20" name="Text 18"/>
+          <p:cNvSpPr txBox="1"/>
+          <p:nvPr/>
+        </p:nvSpPr>
+        <p:spPr>
+          <a:xfrm>
+            <a:off x="8046720" y="1325880"/>
+            <a:ext cx="3383280" cy="411480"/>
+          </a:xfrm>
+          <a:prstGeom prst="rect">
+            <a:avLst/>
+          </a:prstGeom>
+          <a:noFill/>
+          <a:ln/>
+        </p:spPr>
+        <p:txBody>
+          <a:bodyPr wrap="square" lIns="0" tIns="0" rIns="0" bIns="0" rtlCol="0" anchor="ctr"/>
+          <a:lstStyle/>
+          <a:p>
+            <a:pPr indent="0" marL="0">
+              <a:buNone/>
+            </a:pPr>
+            <a:r>
+              <a:rPr lang="en-US" sz="2000" b="1" dirty="0">
+                <a:solidFill>
+                  <a:srgbClr val="E8702A"/>
+                </a:solidFill>
+                <a:latin typeface="Cambria" pitchFamily="34" charset="0"/>
+                <a:ea typeface="Cambria" pitchFamily="34" charset="-122"/>
+                <a:cs typeface="Cambria" pitchFamily="34" charset="-120"/>
+              </a:rPr>
+              <a:t>Trabajo futuro</a:t>
+            </a:r>
+            <a:endParaRPr lang="en-US" sz="2000" dirty="0"/>
+          </a:p>
+        </p:txBody>
+      </p:sp>
+      <p:sp>
+        <p:nvSpPr>
+          <p:cNvPr id="21" name="Text 19"/>
+          <p:cNvSpPr txBox="1"/>
+          <p:nvPr/>
+        </p:nvSpPr>
+        <p:spPr>
+          <a:xfrm>
+            <a:off x="8046720" y="1874520"/>
+            <a:ext cx="3383280" cy="3703320"/>
+          </a:xfrm>
+          <a:prstGeom prst="rect">
+            <a:avLst/>
+          </a:prstGeom>
+          <a:noFill/>
+          <a:ln/>
+        </p:spPr>
+        <p:txBody>
+          <a:bodyPr wrap="square" lIns="0" tIns="0" rIns="0" bIns="0" rtlCol="0" anchor="t"/>
+          <a:lstStyle/>
+          <a:p>
+            <a:pPr indent="0" marL="0">
+              <a:spcAft>
+                <a:spcPts val="900"/>
+              </a:spcAft>
+              <a:buNone/>
+            </a:pPr>
+            <a:r>
+              <a:rPr lang="en-US" sz="1500" b="1" dirty="0">
+                <a:solidFill>
+                  <a:srgbClr val="FFFFFF"/>
+                </a:solidFill>
+              </a:rPr>
+              <a:t>NRHO de Gateway</a:t>
+            </a:r>
+            <a:endParaRPr lang="en-US" sz="1500" dirty="0"/>
+          </a:p>
+          <a:p>
+            <a:pPr indent="0" marL="0">
+              <a:spcAft>
+                <a:spcPts val="900"/>
+              </a:spcAft>
+              <a:buNone/>
+            </a:pPr>
+            <a:r>
+              <a:rPr lang="en-US" sz="1500" dirty="0">
+                <a:solidFill>
+                  <a:srgbClr val="CADCFC"/>
+                </a:solidFill>
+              </a:rPr>
+              <a:t>Órbitas de halo L2 por corrección diferencial</a:t>
+            </a:r>
+            <a:endParaRPr lang="en-US" sz="1500" dirty="0"/>
+          </a:p>
+          <a:p>
+            <a:pPr indent="0" marL="0">
+              <a:spcAft>
+                <a:spcPts val="900"/>
+              </a:spcAft>
+              <a:buNone/>
+            </a:pPr>
+            <a:r>
+              <a:rPr lang="en-US" sz="1500" b="1" dirty="0">
+                <a:solidFill>
+                  <a:srgbClr val="FFFFFF"/>
+                </a:solidFill>
+              </a:rPr>
+              <a:t>Descenso del HLS</a:t>
+            </a:r>
+            <a:endParaRPr lang="en-US" sz="1500" dirty="0"/>
+          </a:p>
+          <a:p>
+            <a:pPr indent="0" marL="0">
+              <a:spcAft>
+                <a:spcPts val="900"/>
+              </a:spcAft>
+              <a:buNone/>
+            </a:pPr>
+            <a:r>
+              <a:rPr lang="en-US" sz="1500" dirty="0">
+                <a:solidFill>
+                  <a:srgbClr val="CADCFC"/>
+                </a:solidFill>
+              </a:rPr>
+              <a:t>Gravedad lunar con mascons (GRAIL)</a:t>
+            </a:r>
+            <a:endParaRPr lang="en-US" sz="1500" dirty="0"/>
+          </a:p>
+          <a:p>
+            <a:pPr indent="0" marL="0">
+              <a:spcAft>
+                <a:spcPts val="900"/>
+              </a:spcAft>
+              <a:buNone/>
+            </a:pPr>
+            <a:r>
+              <a:rPr lang="en-US" sz="1500" b="1" dirty="0">
+                <a:solidFill>
+                  <a:srgbClr val="FFFFFF"/>
+                </a:solidFill>
+              </a:rPr>
+              <a:t>Mayor fidelidad</a:t>
+            </a:r>
+            <a:endParaRPr lang="en-US" sz="1500" dirty="0"/>
+          </a:p>
+          <a:p>
+            <a:pPr indent="0" marL="0">
+              <a:spcAft>
+                <a:spcPts val="900"/>
+              </a:spcAft>
+              <a:buNone/>
+            </a:pPr>
+            <a:r>
+              <a:rPr lang="en-US" sz="1500" dirty="0">
+                <a:solidFill>
+                  <a:srgbClr val="CADCFC"/>
+                </a:solidFill>
+              </a:rPr>
+              <a:t>Efemérides DE440, Sol, J₂, combustiones finitas</a:t>
+            </a:r>
+            <a:endParaRPr lang="en-US" sz="1500" dirty="0"/>
+          </a:p>
+          <a:p>
+            <a:pPr indent="0" marL="0">
+              <a:spcAft>
+                <a:spcPts val="900"/>
+              </a:spcAft>
+              <a:buNone/>
+            </a:pPr>
+            <a:r>
+              <a:rPr lang="en-US" sz="1500" b="1" dirty="0">
+                <a:solidFill>
+                  <a:srgbClr val="FFFFFF"/>
+                </a:solidFill>
+              </a:rPr>
+              <a:t>Visualización 3D</a:t>
+            </a:r>
+            <a:endParaRPr lang="en-US" sz="1500" dirty="0"/>
+          </a:p>
+          <a:p>
+            <a:pPr indent="0" marL="0">
+              <a:spcAft>
+                <a:spcPts val="900"/>
+              </a:spcAft>
+              <a:buNone/>
+            </a:pPr>
+            <a:r>
+              <a:rPr lang="en-US" sz="1500" dirty="0">
+                <a:solidFill>
+                  <a:srgbClr val="CADCFC"/>
+                </a:solidFill>
+              </a:rPr>
+              <a:t>Trayectorias en Three.js</a:t>
+            </a:r>
+            <a:endParaRPr lang="en-US" sz="1500" dirty="0"/>
           </a:p>
         </p:txBody>
       </p:sp>
@@ -12891,516 +12030,6 @@
 <file path=ppt/slides/slide23.xml><?xml version="1.0" encoding="utf-8"?>
 <p:sld xmlns:a="http://schemas.openxmlformats.org/drawingml/2006/main" xmlns:r="http://schemas.openxmlformats.org/officeDocument/2006/relationships" xmlns:p="http://schemas.openxmlformats.org/presentationml/2006/main">
   <p:cSld name="Slide 23">
-    <p:spTree>
-      <p:nvGrpSpPr>
-        <p:cNvPr id="1" name=""/>
-        <p:cNvGrpSpPr/>
-        <p:nvPr/>
-      </p:nvGrpSpPr>
-      <p:grpSpPr>
-        <a:xfrm>
-          <a:off x="0" y="0"/>
-          <a:ext cx="0" cy="0"/>
-          <a:chOff x="0" y="0"/>
-          <a:chExt cx="0" cy="0"/>
-        </a:xfrm>
-      </p:grpSpPr>
-      <p:sp>
-        <p:nvSpPr>
-          <p:cNvPr id="2" name="Text 0"/>
-          <p:cNvSpPr/>
-          <p:nvPr>
-            <p:ph idx="101" type="title" hasCustomPrompt="1"/>
-          </p:nvPr>
-        </p:nvSpPr>
-        <p:spPr>
-          <a:xfrm>
-            <a:off x="548640" y="320040"/>
-            <a:ext cx="11094415" cy="731520"/>
-          </a:xfrm>
-          <a:prstGeom prst="rect">
-            <a:avLst/>
-          </a:prstGeom>
-          <a:noFill/>
-          <a:ln/>
-        </p:spPr>
-        <p:txBody>
-          <a:bodyPr wrap="square" lIns="0" tIns="0" rIns="0" bIns="0" rtlCol="0" anchor="ctr"/>
-          <a:lstStyle/>
-          <a:p>
-            <a:pPr indent="0" marL="0">
-              <a:buNone/>
-            </a:pPr>
-            <a:r>
-              <a:rPr lang="en-US" sz="3000" b="1" dirty="0">
-                <a:solidFill>
-                  <a:srgbClr val="0B1D3A"/>
-                </a:solidFill>
-                <a:latin typeface="Cambria" pitchFamily="34" charset="0"/>
-                <a:ea typeface="Cambria" pitchFamily="34" charset="-122"/>
-                <a:cs typeface="Cambria" pitchFamily="34" charset="-120"/>
-              </a:rPr>
-              <a:t>Conclusiones y trabajo futuro</a:t>
-            </a:r>
-            <a:endParaRPr lang="en-US" sz="3000" dirty="0"/>
-          </a:p>
-        </p:txBody>
-      </p:sp>
-      <p:sp>
-        <p:nvSpPr>
-          <p:cNvPr id="3" name="Text 1"/>
-          <p:cNvSpPr txBox="1"/>
-          <p:nvPr/>
-        </p:nvSpPr>
-        <p:spPr>
-          <a:xfrm>
-            <a:off x="548640" y="1188720"/>
-            <a:ext cx="5486400" cy="411480"/>
-          </a:xfrm>
-          <a:prstGeom prst="rect">
-            <a:avLst/>
-          </a:prstGeom>
-          <a:noFill/>
-          <a:ln/>
-        </p:spPr>
-        <p:txBody>
-          <a:bodyPr wrap="square" lIns="0" tIns="0" rIns="0" bIns="0" rtlCol="0" anchor="ctr"/>
-          <a:lstStyle/>
-          <a:p>
-            <a:pPr indent="0" marL="0">
-              <a:buNone/>
-            </a:pPr>
-            <a:r>
-              <a:rPr lang="en-US" sz="2000" b="1" dirty="0">
-                <a:solidFill>
-                  <a:srgbClr val="E8702A"/>
-                </a:solidFill>
-                <a:latin typeface="Cambria" pitchFamily="34" charset="0"/>
-                <a:ea typeface="Cambria" pitchFamily="34" charset="-122"/>
-                <a:cs typeface="Cambria" pitchFamily="34" charset="-120"/>
-              </a:rPr>
-              <a:t>Conclusiones</a:t>
-            </a:r>
-            <a:endParaRPr lang="en-US" sz="2000" dirty="0"/>
-          </a:p>
-        </p:txBody>
-      </p:sp>
-      <p:sp>
-        <p:nvSpPr>
-          <p:cNvPr id="4" name="Text 2"/>
-          <p:cNvSpPr txBox="1"/>
-          <p:nvPr/>
-        </p:nvSpPr>
-        <p:spPr>
-          <a:xfrm>
-            <a:off x="548640" y="1737360"/>
-            <a:ext cx="5486400" cy="3840480"/>
-          </a:xfrm>
-          <a:prstGeom prst="rect">
-            <a:avLst/>
-          </a:prstGeom>
-          <a:noFill/>
-          <a:ln/>
-        </p:spPr>
-        <p:txBody>
-          <a:bodyPr wrap="square" lIns="0" tIns="0" rIns="0" bIns="0" rtlCol="0" anchor="t"/>
-          <a:lstStyle/>
-          <a:p>
-            <a:pPr marL="342900" indent="-342900">
-              <a:spcAft>
-                <a:spcPts val="800"/>
-              </a:spcAft>
-              <a:buSzPct val="100000"/>
-              <a:buChar char="•"/>
-            </a:pPr>
-            <a:r>
-              <a:rPr lang="en-US" sz="1500" dirty="0">
-                <a:solidFill>
-                  <a:srgbClr val="1B1B1F"/>
-                </a:solidFill>
-              </a:rPr>
-              <a:t>Simulador modular y verificado de 3 fases de Artemis IV</a:t>
-            </a:r>
-            <a:endParaRPr lang="en-US" sz="1500" dirty="0"/>
-          </a:p>
-          <a:p>
-            <a:pPr marL="342900" indent="-342900">
-              <a:spcAft>
-                <a:spcPts val="800"/>
-              </a:spcAft>
-              <a:buSzPct val="100000"/>
-              <a:buChar char="•"/>
-            </a:pPr>
-            <a:r>
-              <a:rPr lang="en-US" sz="1500" dirty="0">
-                <a:solidFill>
-                  <a:srgbClr val="1B1B1F"/>
-                </a:solidFill>
-              </a:rPr>
-              <a:t>Resultados coherentes con el SLS: Max-Q de 27.5 kPa, TLI de 3.15 km/s</a:t>
-            </a:r>
-            <a:endParaRPr lang="en-US" sz="1500" dirty="0"/>
-          </a:p>
-          <a:p>
-            <a:pPr marL="342900" indent="-342900">
-              <a:spcAft>
-                <a:spcPts val="800"/>
-              </a:spcAft>
-              <a:buSzPct val="100000"/>
-              <a:buChar char="•"/>
-            </a:pPr>
-            <a:r>
-              <a:rPr lang="en-US" sz="1500" dirty="0">
-                <a:solidFill>
-                  <a:srgbClr val="1B1B1F"/>
-                </a:solidFill>
-              </a:rPr>
-              <a:t>Integrador simpléctico: error acotado frente a la deriva de RK4</a:t>
-            </a:r>
-            <a:endParaRPr lang="en-US" sz="1500" dirty="0"/>
-          </a:p>
-          <a:p>
-            <a:pPr marL="342900" indent="-342900">
-              <a:spcAft>
-                <a:spcPts val="800"/>
-              </a:spcAft>
-              <a:buSzPct val="100000"/>
-              <a:buChar char="•"/>
-            </a:pPr>
-            <a:r>
-              <a:rPr lang="en-US" sz="1500" dirty="0">
-                <a:solidFill>
-                  <a:srgbClr val="1B1B1F"/>
-                </a:solidFill>
-              </a:rPr>
-              <a:t>Con la Luna, el invariante es Jacobi y no la energía</a:t>
-            </a:r>
-            <a:endParaRPr lang="en-US" sz="1500" dirty="0"/>
-          </a:p>
-          <a:p>
-            <a:pPr marL="342900" indent="-342900">
-              <a:spcAft>
-                <a:spcPts val="800"/>
-              </a:spcAft>
-              <a:buSzPct val="100000"/>
-              <a:buChar char="•"/>
-            </a:pPr>
-            <a:r>
-              <a:rPr lang="en-US" sz="1500" dirty="0">
-                <a:solidFill>
-                  <a:srgbClr val="1B1B1F"/>
-                </a:solidFill>
-              </a:rPr>
-              <a:t>Una buena semilla (Kepler) es decisiva para Newton</a:t>
-            </a:r>
-            <a:endParaRPr lang="en-US" sz="1500" dirty="0"/>
-          </a:p>
-        </p:txBody>
-      </p:sp>
-      <p:sp>
-        <p:nvSpPr>
-          <p:cNvPr id="5" name="Shape 3"/>
-          <p:cNvSpPr/>
-          <p:nvPr/>
-        </p:nvSpPr>
-        <p:spPr>
-          <a:xfrm>
-            <a:off x="6400800" y="1188720"/>
-            <a:ext cx="5212080" cy="3840480"/>
-          </a:xfrm>
-          <a:prstGeom prst="roundRect">
-            <a:avLst>
-              <a:gd name="adj" fmla="val 2381"/>
-            </a:avLst>
-          </a:prstGeom>
-          <a:solidFill>
-            <a:srgbClr val="EEF2F7"/>
-          </a:solidFill>
-          <a:ln w="12700">
-            <a:solidFill>
-              <a:srgbClr val="EEF2F7"/>
-            </a:solidFill>
-            <a:prstDash val="solid"/>
-          </a:ln>
-        </p:spPr>
-      </p:sp>
-      <p:sp>
-        <p:nvSpPr>
-          <p:cNvPr id="6" name="Text 4"/>
-          <p:cNvSpPr txBox="1"/>
-          <p:nvPr/>
-        </p:nvSpPr>
-        <p:spPr>
-          <a:xfrm>
-            <a:off x="6629400" y="1325880"/>
-            <a:ext cx="4754880" cy="411480"/>
-          </a:xfrm>
-          <a:prstGeom prst="rect">
-            <a:avLst/>
-          </a:prstGeom>
-          <a:noFill/>
-          <a:ln/>
-        </p:spPr>
-        <p:txBody>
-          <a:bodyPr wrap="square" lIns="0" tIns="0" rIns="0" bIns="0" rtlCol="0" anchor="ctr"/>
-          <a:lstStyle/>
-          <a:p>
-            <a:pPr indent="0" marL="0">
-              <a:buNone/>
-            </a:pPr>
-            <a:r>
-              <a:rPr lang="en-US" sz="2000" b="1" dirty="0">
-                <a:solidFill>
-                  <a:srgbClr val="0B1D3A"/>
-                </a:solidFill>
-                <a:latin typeface="Cambria" pitchFamily="34" charset="0"/>
-                <a:ea typeface="Cambria" pitchFamily="34" charset="-122"/>
-                <a:cs typeface="Cambria" pitchFamily="34" charset="-120"/>
-              </a:rPr>
-              <a:t>Trabajo futuro</a:t>
-            </a:r>
-            <a:endParaRPr lang="en-US" sz="2000" dirty="0"/>
-          </a:p>
-        </p:txBody>
-      </p:sp>
-      <p:sp>
-        <p:nvSpPr>
-          <p:cNvPr id="7" name="Text 5"/>
-          <p:cNvSpPr txBox="1"/>
-          <p:nvPr/>
-        </p:nvSpPr>
-        <p:spPr>
-          <a:xfrm>
-            <a:off x="6629400" y="1828800"/>
-            <a:ext cx="4754880" cy="3657600"/>
-          </a:xfrm>
-          <a:prstGeom prst="rect">
-            <a:avLst/>
-          </a:prstGeom>
-          <a:noFill/>
-          <a:ln/>
-        </p:spPr>
-        <p:txBody>
-          <a:bodyPr wrap="square" lIns="0" tIns="0" rIns="0" bIns="0" rtlCol="0" anchor="t"/>
-          <a:lstStyle/>
-          <a:p>
-            <a:pPr marL="342900" indent="-342900">
-              <a:spcAft>
-                <a:spcPts val="800"/>
-              </a:spcAft>
-              <a:buSzPct val="100000"/>
-              <a:buChar char="•"/>
-            </a:pPr>
-            <a:r>
-              <a:rPr lang="en-US" sz="1450" b="1" dirty="0">
-                <a:solidFill>
-                  <a:srgbClr val="1B1B1F"/>
-                </a:solidFill>
-              </a:rPr>
-              <a:t>NRHO: </a:t>
-            </a:r>
-            <a:pPr indent="0" marL="0">
-              <a:spcAft>
-                <a:spcPts val="800"/>
-              </a:spcAft>
-              <a:buNone/>
-            </a:pPr>
-            <a:r>
-              <a:rPr lang="en-US" sz="1450" dirty="0">
-                <a:solidFill>
-                  <a:srgbClr val="1B1B1F"/>
-                </a:solidFill>
-              </a:rPr>
-              <a:t>órbitas de halo L2 sur por corrección diferencial</a:t>
-            </a:r>
-            <a:endParaRPr lang="en-US" sz="1450" dirty="0"/>
-          </a:p>
-          <a:p>
-            <a:pPr marL="342900" indent="-342900">
-              <a:spcAft>
-                <a:spcPts val="800"/>
-              </a:spcAft>
-              <a:buSzPct val="100000"/>
-              <a:buChar char="•"/>
-            </a:pPr>
-            <a:r>
-              <a:rPr lang="en-US" sz="1450" b="1" dirty="0">
-                <a:solidFill>
-                  <a:srgbClr val="1B1B1F"/>
-                </a:solidFill>
-              </a:rPr>
-              <a:t>Descenso HLS: </a:t>
-            </a:r>
-            <a:pPr indent="0" marL="0">
-              <a:spcAft>
-                <a:spcPts val="800"/>
-              </a:spcAft>
-              <a:buNone/>
-            </a:pPr>
-            <a:r>
-              <a:rPr lang="en-US" sz="1450" dirty="0">
-                <a:solidFill>
-                  <a:srgbClr val="1B1B1F"/>
-                </a:solidFill>
-              </a:rPr>
-              <a:t>armónicos esféricos GRGM1200A (mascons de GRAIL)</a:t>
-            </a:r>
-            <a:endParaRPr lang="en-US" sz="1450" dirty="0"/>
-          </a:p>
-          <a:p>
-            <a:pPr marL="342900" indent="-342900">
-              <a:spcAft>
-                <a:spcPts val="800"/>
-              </a:spcAft>
-              <a:buSzPct val="100000"/>
-              <a:buChar char="•"/>
-            </a:pPr>
-            <a:r>
-              <a:rPr lang="en-US" sz="1450" b="1" dirty="0">
-                <a:solidFill>
-                  <a:srgbClr val="1B1B1F"/>
-                </a:solidFill>
-              </a:rPr>
-              <a:t>Efemérides: </a:t>
-            </a:r>
-            <a:pPr indent="0" marL="0">
-              <a:spcAft>
-                <a:spcPts val="800"/>
-              </a:spcAft>
-              <a:buNone/>
-            </a:pPr>
-            <a:r>
-              <a:rPr lang="en-US" sz="1450" dirty="0">
-                <a:solidFill>
-                  <a:srgbClr val="1B1B1F"/>
-                </a:solidFill>
-              </a:rPr>
-              <a:t>JPL DE440, Sol, J₂ y presión de radiación</a:t>
-            </a:r>
-            <a:endParaRPr lang="en-US" sz="1450" dirty="0"/>
-          </a:p>
-          <a:p>
-            <a:pPr marL="342900" indent="-342900">
-              <a:spcAft>
-                <a:spcPts val="800"/>
-              </a:spcAft>
-              <a:buSzPct val="100000"/>
-              <a:buChar char="•"/>
-            </a:pPr>
-            <a:r>
-              <a:rPr lang="en-US" sz="1450" b="1" dirty="0">
-                <a:solidFill>
-                  <a:srgbClr val="1B1B1F"/>
-                </a:solidFill>
-              </a:rPr>
-              <a:t>Combustiones finitas </a:t>
-            </a:r>
-            <a:pPr indent="0" marL="0">
-              <a:spcAft>
-                <a:spcPts val="800"/>
-              </a:spcAft>
-              <a:buNone/>
-            </a:pPr>
-            <a:r>
-              <a:rPr lang="en-US" sz="1450" dirty="0">
-                <a:solidFill>
-                  <a:srgbClr val="1B1B1F"/>
-                </a:solidFill>
-              </a:rPr>
-              <a:t>de la EUS y optimización del ascenso</a:t>
-            </a:r>
-            <a:endParaRPr lang="en-US" sz="1450" dirty="0"/>
-          </a:p>
-          <a:p>
-            <a:pPr marL="342900" indent="-342900">
-              <a:spcAft>
-                <a:spcPts val="800"/>
-              </a:spcAft>
-              <a:buSzPct val="100000"/>
-              <a:buChar char="•"/>
-            </a:pPr>
-            <a:r>
-              <a:rPr lang="en-US" sz="1450" b="1" dirty="0">
-                <a:solidFill>
-                  <a:srgbClr val="1B1B1F"/>
-                </a:solidFill>
-              </a:rPr>
-              <a:t>Visualización 3D </a:t>
-            </a:r>
-            <a:pPr indent="0" marL="0">
-              <a:spcAft>
-                <a:spcPts val="800"/>
-              </a:spcAft>
-              <a:buNone/>
-            </a:pPr>
-            <a:r>
-              <a:rPr lang="en-US" sz="1450" dirty="0">
-                <a:solidFill>
-                  <a:srgbClr val="1B1B1F"/>
-                </a:solidFill>
-              </a:rPr>
-              <a:t>con Three.js (frontend del repositorio)</a:t>
-            </a:r>
-            <a:endParaRPr lang="en-US" sz="1450" dirty="0"/>
-          </a:p>
-        </p:txBody>
-      </p:sp>
-      <p:sp>
-        <p:nvSpPr>
-          <p:cNvPr id="25" name="Slide Number Placeholder 0"/>
-          <p:cNvSpPr>
-            <a:spLocks noGrp="1"/>
-          </p:cNvSpPr>
-          <p:nvPr>
-            <p:ph type="sldNum" sz="quarter" idx="4294967295"/>
-          </p:nvPr>
-        </p:nvSpPr>
-        <p:spPr>
-          <a:xfrm>
-            <a:off x="548640" y="6400800"/>
-            <a:ext cx="548640" cy="274320"/>
-          </a:xfrm>
-          <a:prstGeom prst="rect">
-            <a:avLst/>
-          </a:prstGeom>
-          <a:extLst>
-            <a:ext uri="{C572A759-6A51-4108-AA02-DFA0A04FC94B}">
-              <ma14:wrappingTextBoxFlag xmlns:ma14="http://schemas.microsoft.com/office/mac/drawingml/2011/main" val="0"/>
-            </a:ext>
-          </a:extLst>
-        </p:spPr>
-        <p:txBody>
-          <a:bodyPr/>
-          <a:lstStyle>
-            <a:lvl1pPr>
-              <a:defRPr sz="1000">
-                <a:solidFill>
-                  <a:srgbClr val="52514E"/>
-                </a:solidFill>
-              </a:defRPr>
-            </a:lvl1pPr>
-          </a:lstStyle>
-          <a:p>
-            <a:pPr algn="l"/>
-            <a:fld id="{F7021451-1387-4CA6-816F-3879F97B5CBC}" type="slidenum">
-              <a:rPr b="0" lang="en-US"/>
-              <a:t>23</a:t>
-            </a:fld>
-            <a:endParaRPr lang="en-US"/>
-          </a:p>
-        </p:txBody>
-      </p:sp>
-    </p:spTree>
-  </p:cSld>
-  <p:clrMapOvr>
-    <a:masterClrMapping/>
-  </p:clrMapOvr>
-</p:sld>
-</file>
-
-<file path=ppt/slides/slide24.xml><?xml version="1.0" encoding="utf-8"?>
-<p:sld xmlns:a="http://schemas.openxmlformats.org/drawingml/2006/main" xmlns:r="http://schemas.openxmlformats.org/officeDocument/2006/relationships" xmlns:p="http://schemas.openxmlformats.org/presentationml/2006/main">
-  <p:cSld name="Slide 24">
     <p:spTree>
       <p:nvGrpSpPr>
         <p:cNvPr id="1" name=""/>
@@ -19161,7 +17790,7 @@
                   <a:srgbClr val="1B1B1F"/>
                 </a:solidFill>
               </a:rPr>
-              <a:t>El borrador mezclaba ECEF (Coriolis/centrífuga) con ECI: corregido</a:t>
+              <a:t>Lanzar hacia el este aprovecha esos 408 m/s de la rotación terrestre</a:t>
             </a:r>
             <a:endParaRPr lang="en-US" sz="1400" dirty="0"/>
           </a:p>
@@ -19624,7 +18253,7 @@
                 <a:ea typeface="Cambria" pitchFamily="34" charset="-122"/>
                 <a:cs typeface="Cambria" pitchFamily="34" charset="-120"/>
               </a:rPr>
-              <a:t>Error encontrado en el código original</a:t>
+              <a:t>Conservación de la masa</a:t>
             </a:r>
             <a:endParaRPr lang="en-US" sz="1700" dirty="0"/>
           </a:p>
@@ -19664,7 +18293,7 @@
                   <a:srgbClr val="1B1B1F"/>
                 </a:solidFill>
               </a:rPr>
-              <a:t>Empuje constante de 16 MN por SRB con Isp de 268 s: el propelente se agota a los 103 s</a:t>
+              <a:t>El grano de PBAN se talla para un empuje regresivo: máximo al despegue y menor cerca de Max-Q</a:t>
             </a:r>
             <a:endParaRPr lang="en-US" sz="1400" dirty="0"/>
           </a:p>
@@ -19682,7 +18311,7 @@
                   <a:srgbClr val="1B1B1F"/>
                 </a:solidFill>
               </a:rPr>
-              <a:t>Pero los SRB seguían encendidos hasta los 126 s</a:t>
+              <a:t>El gasto másico sigue al empuje: ṁ(t) = T(t) / (Isp·g₀)</a:t>
             </a:r>
             <a:endParaRPr lang="en-US" sz="1400" dirty="0"/>
           </a:p>
@@ -19700,7 +18329,7 @@
                   <a:srgbClr val="1B1B1F"/>
                 </a:solidFill>
               </a:rPr>
-              <a:t>Consumían unas 280 t de masa del Core Stage</a:t>
+              <a:t>En 126 s los SRB queman exactamente sus 1 257 t de propelente</a:t>
             </a:r>
             <a:endParaRPr lang="en-US" sz="1400" dirty="0"/>
           </a:p>
@@ -19718,7 +18347,7 @@
                   <a:srgbClr val="1B1B1F"/>
                 </a:solidFill>
               </a:rPr>
-              <a:t>Solución: </a:t>
+              <a:t>Condición: </a:t>
             </a:r>
             <a:pPr indent="0" marL="0">
               <a:spcAft>
@@ -19732,7 +18361,7 @@
                   <a:srgbClr val="1B1B1F"/>
                 </a:solidFill>
               </a:rPr>
-              <a:t>el perfil f(t) se escala con k para que ∫ṁ dt = m_p exactamente</a:t>
+              <a:t>∫ṁ dt = m_p fija el factor de escala k</a:t>
             </a:r>
             <a:endParaRPr lang="en-US" sz="1400" dirty="0"/>
           </a:p>
@@ -19834,7 +18463,7 @@
                   <a:srgbClr val="52514E"/>
                 </a:solidFill>
               </a:rPr>
-              <a:t>factor k: los datos públicos son coherentes</a:t>
+              <a:t>factor k ≈ 1: los datos públicos son coherentes</a:t>
             </a:r>
             <a:endParaRPr lang="en-US" sz="1250" dirty="0"/>
           </a:p>
@@ -19994,47 +18623,47 @@
 </file>
 
 <file path=ppt/theme/theme1.xml><?xml version="1.0" encoding="utf-8"?>
-<a:theme xmlns:a="http://schemas.openxmlformats.org/drawingml/2006/main" name="Artemis UdeM">
+<a:theme xmlns:a="http://schemas.openxmlformats.org/drawingml/2006/main" name="Office Theme">
   <a:themeElements>
-    <a:clrScheme name="Artemis UdeM">
+    <a:clrScheme name="Office">
       <a:dk1>
-        <a:srgbClr val="1B1B1F"/>
+        <a:sysClr val="windowText" lastClr="000000"/>
       </a:dk1>
       <a:lt1>
-        <a:srgbClr val="FFFFFF"/>
+        <a:sysClr val="window" lastClr="FFFFFF"/>
       </a:lt1>
       <a:dk2>
-        <a:srgbClr val="0B1D3A"/>
+        <a:srgbClr val="44546A"/>
       </a:dk2>
       <a:lt2>
-        <a:srgbClr val="EEF2F7"/>
+        <a:srgbClr val="E7E6E6"/>
       </a:lt2>
       <a:accent1>
-        <a:srgbClr val="E8702A"/>
+        <a:srgbClr val="4472C4"/>
       </a:accent1>
       <a:accent2>
-        <a:srgbClr val="2A78D6"/>
+        <a:srgbClr val="ED7D31"/>
       </a:accent2>
       <a:accent3>
-        <a:srgbClr val="1BAF7A"/>
+        <a:srgbClr val="A5A5A5"/>
       </a:accent3>
       <a:accent4>
-        <a:srgbClr val="EDA100"/>
+        <a:srgbClr val="FFC000"/>
       </a:accent4>
       <a:accent5>
-        <a:srgbClr val="6250D6"/>
+        <a:srgbClr val="5B9BD5"/>
       </a:accent5>
       <a:accent6>
-        <a:srgbClr val="52514E"/>
+        <a:srgbClr val="70AD47"/>
       </a:accent6>
       <a:hlink>
-        <a:srgbClr val="2A78D6"/>
+        <a:srgbClr val="0563C1"/>
       </a:hlink>
       <a:folHlink>
-        <a:srgbClr val="6250D6"/>
+        <a:srgbClr val="954F72"/>
       </a:folHlink>
     </a:clrScheme>
-    <a:fontScheme name="Artemis UdeM">
+    <a:fontScheme name="Office">
       <a:majorFont>
         <a:latin typeface="Cambria"/>
         <a:ea typeface=""/>

</xml_diff>